<commit_message>
Add agents and skills to the 30-minute intro talk
Agents and skills were absent from the standalone overview — a real gap
for a 2026 audience, since agents are where "working with AI" is heading
and skills are how you make it consistent. Added:

- talk.md §7 "When the model acts: agents and skills" — agent = LLM with
  tools + a Think-Act-Observe loop; skill = a saved, reusable procedure;
  the prompt -> skill -> agent ladder; and the safety point that once AI
  acts on its output, "own the output" matters more, not less.
- A new slide 15 with the ladder diagram (deck now 17 slides).
- Sixth takeaway; agenda, intro, and "where next" pointers updated to
  point at Sessions 11-12 for depth.

Co-Authored-By: Claude Opus 4.8 <noreply@anthropic.com>
</commit_message>
<xml_diff>
--- a/training/decks/overview-30min.pptx
+++ b/training/decks/overview-30min.pptx
@@ -21,6 +21,7 @@
     <p:sldId id="269" r:id="rId21"/>
     <p:sldId id="270" r:id="rId22"/>
     <p:sldId id="271" r:id="rId23"/>
+    <p:sldId id="272" r:id="rId24"/>
   </p:sldIdLst>
   <p:sldSz cx="12191695" cy="6858000" type="screen4x3"/>
   <p:notesSz cx="6858000" cy="9144000"/>
@@ -989,7 +990,23 @@
           <a:lstStyle/>
           <a:p>
             <a:r>
-              <a:t>Recap the arc. Then the one sentence to leave in the room: an LLM is a fluent, confident, sometimes-wrong assistant — brilliant when you can check its work, dangerous when you can't. Treat it accordingly. Point to the full course for anyone who wants more.</a:t>
+              <a:t>This is the "where it's going" slide, and it was flagged as important — give it real weight. An agent doesn't just reply; it uses tools in a Think–Act–Observe loop until the job is done. A skill is a written procedure the model reuses, so it is consistent and expert at YOUR tasks rather than generically capable. Walk the prompt→skill→agent ladder. Then the safety line, which is the whole point: a wrong chatbot answer is an embarrassment you catch on reading; a wrong answer from an agent that already filed the ticket or ran the command is an incident. Start narrow, keep a human gate. The full course goes deep — Sessions 11 (skills, MCP, working with Claude) and 12 (agents).</a:t>
+            </a:r>
+          </a:p>
+          <a:p/>
+          <a:p>
+            <a:r>
+              <a:t>--- Mermaid source 1 (render and place on the diagram box) ---</a:t>
+            </a:r>
+          </a:p>
+          <a:p>
+            <a:r>
+              <a:t>flowchart LR</a:t>
+            </a:r>
+          </a:p>
+          <a:p>
+            <a:r>
+              <a:t>    P["Prompt&lt;br/&gt;one-off instruction"] --&gt; S["Skill&lt;br/&gt;saved reusable procedure"] --&gt; A["Agent&lt;br/&gt;acts with tools in a loop"]</a:t>
             </a:r>
           </a:p>
         </p:txBody>
@@ -1059,7 +1076,77 @@
           <a:lstStyle/>
           <a:p>
             <a:r>
-              <a:t>Open the floor. Common questions to expect: is our data safe to paste (depends — treat as external), will it replace jobs (see Session 15), which tool is best (they're similar; the skill transfers). Point to the glossary and the full series.</a:t>
+              <a:t>Recap the arc. Then the one sentence to leave in the room: an LLM is a fluent, confident, sometimes-wrong assistant — brilliant when you can check its work, dangerous when you can't. Treat it accordingly, especially once you let it act. Point to the full course for anyone who wants more.</a:t>
+            </a:r>
+          </a:p>
+        </p:txBody>
+      </p:sp>
+      <p:sp>
+        <p:nvSpPr>
+          <p:cNvPr id="4" name="Slide Number Placeholder 3"/>
+          <p:cNvSpPr>
+            <a:spLocks noGrp="1"/>
+          </p:cNvSpPr>
+          <p:nvPr>
+            <p:ph type="sldNum" idx="5" sz="quarter"/>
+          </p:nvPr>
+        </p:nvSpPr>
+        <p:spPr/>
+      </p:sp>
+    </p:spTree>
+  </p:cSld>
+  <p:clrMapOvr>
+    <a:masterClrMapping/>
+  </p:clrMapOvr>
+</p:notes>
+</file>
+
+<file path=ppt/notesSlides/notesSlide17.xml><?xml version="1.0" encoding="utf-8"?>
+<p:notes xmlns:a="http://schemas.openxmlformats.org/drawingml/2006/main" xmlns:p="http://schemas.openxmlformats.org/presentationml/2006/main" xmlns:r="http://schemas.openxmlformats.org/officeDocument/2006/relationships">
+  <p:cSld>
+    <p:spTree>
+      <p:nvGrpSpPr>
+        <p:cNvPr id="1" name=""/>
+        <p:cNvGrpSpPr/>
+        <p:nvPr/>
+      </p:nvGrpSpPr>
+      <p:grpSpPr>
+        <a:xfrm>
+          <a:off x="0" y="0"/>
+          <a:ext cx="0" cy="0"/>
+          <a:chOff x="0" y="0"/>
+          <a:chExt cx="0" cy="0"/>
+        </a:xfrm>
+      </p:grpSpPr>
+      <p:sp>
+        <p:nvSpPr>
+          <p:cNvPr id="2" name="Slide Image Placeholder 1"/>
+          <p:cNvSpPr>
+            <a:spLocks noGrp="1"/>
+          </p:cNvSpPr>
+          <p:nvPr>
+            <p:ph type="sldImg" idx="2"/>
+          </p:nvPr>
+        </p:nvSpPr>
+        <p:spPr/>
+      </p:sp>
+      <p:sp>
+        <p:nvSpPr>
+          <p:cNvPr id="3" name="Notes Placeholder 2"/>
+          <p:cNvSpPr>
+            <a:spLocks noGrp="1"/>
+          </p:cNvSpPr>
+          <p:nvPr>
+            <p:ph type="body" idx="3" sz="quarter"/>
+          </p:nvPr>
+        </p:nvSpPr>
+        <p:spPr/>
+        <p:txBody>
+          <a:bodyPr/>
+          <a:lstStyle/>
+          <a:p>
+            <a:r>
+              <a:t>Open the floor. Common questions to expect: is our data safe to paste (depends — treat as external), will it replace jobs (see Session 15), which tool is best (they're similar; the skill transfers), can it just do the task for me (that's agents — Session 12). Point to the glossary and the full series.</a:t>
             </a:r>
           </a:p>
         </p:txBody>
@@ -1129,7 +1216,7 @@
           <a:lstStyle/>
           <a:p>
             <a:r>
-              <a:t>Five beats, each builds on the last. Flag that beat three — why it makes things up — is the one that changes how you use these tools, and that beats four and five are the practical payoff.</a:t>
+              <a:t>Six beats, each builds on the last. Flag that beat three — why it makes things up — is the one that changes how you use these tools; beats four and five are the practical payoff; beat six is where the field is heading and was specifically asked for. Keep the pace up — this is 30 minutes, not 45.</a:t>
             </a:r>
           </a:p>
           <a:p/>
@@ -1145,7 +1232,7 @@
           </a:p>
           <a:p>
             <a:r>
-              <a:t>    A["What AI is"] --&gt; B["How it works"] --&gt; C["Why it lies"] --&gt; D["Working with it"] --&gt; E["Good prompts"]</a:t>
+              <a:t>    A["What AI is"] --&gt; B["How it works"] --&gt; C["Why it lies"] --&gt; D["Working with it"] --&gt; E["Good prompts"] --&gt; F["Agents &amp; skills"]</a:t>
             </a:r>
           </a:p>
         </p:txBody>
@@ -6438,7 +6525,7 @@
                 </a:solidFill>
                 <a:latin typeface="Segoe UI"/>
               </a:rPr>
-              <a:t>Take away five things</a:t>
+              <a:t>Next: when the model acts, not just answers</a:t>
             </a:r>
           </a:p>
         </p:txBody>
@@ -6495,8 +6582,8 @@
         </p:nvSpPr>
         <p:spPr>
           <a:xfrm>
-            <a:off x="822960" y="1691640"/>
-            <a:ext cx="10424160" cy="4023360"/>
+            <a:off x="640080" y="1463040"/>
+            <a:ext cx="4937760" cy="4206240"/>
           </a:xfrm>
           <a:prstGeom prst="rect">
             <a:avLst/>
@@ -6515,7 +6602,7 @@
               </a:spcAft>
             </a:pPr>
             <a:r>
-              <a:rPr sz="2100">
+              <a:rPr sz="1700">
                 <a:solidFill>
                   <a:srgbClr val="2563EB"/>
                 </a:solidFill>
@@ -6524,13 +6611,13 @@
               <a:t>▪  </a:t>
             </a:r>
             <a:r>
-              <a:rPr sz="2100">
+              <a:rPr sz="1700">
                 <a:solidFill>
                   <a:srgbClr val="111827"/>
                 </a:solidFill>
                 <a:latin typeface="Segoe UI"/>
               </a:rPr>
-              <a:t>1. Learns from examples, not rules</a:t>
+              <a:t>Agent = an LLM given tools + a loop → it can act (search, run code, file a ticket)</a:t>
             </a:r>
           </a:p>
           <a:p>
@@ -6540,7 +6627,7 @@
               </a:spcAft>
             </a:pPr>
             <a:r>
-              <a:rPr sz="2100">
+              <a:rPr sz="1700">
                 <a:solidFill>
                   <a:srgbClr val="2563EB"/>
                 </a:solidFill>
@@ -6549,13 +6636,13 @@
               <a:t>▪  </a:t>
             </a:r>
             <a:r>
-              <a:rPr sz="2100">
+              <a:rPr sz="1700">
                 <a:solidFill>
                   <a:srgbClr val="111827"/>
                 </a:solidFill>
                 <a:latin typeface="Segoe UI"/>
               </a:rPr>
-              <a:t>2. Autocomplete on steroids — doesn't look things up</a:t>
+              <a:t>Skill = a saved, reusable procedure that teaches it your way of doing a task</a:t>
             </a:r>
           </a:p>
           <a:p>
@@ -6565,7 +6652,7 @@
               </a:spcAft>
             </a:pPr>
             <a:r>
-              <a:rPr sz="2100">
+              <a:rPr sz="1700">
                 <a:solidFill>
                   <a:srgbClr val="2563EB"/>
                 </a:solidFill>
@@ -6574,13 +6661,13 @@
               <a:t>▪  </a:t>
             </a:r>
             <a:r>
-              <a:rPr sz="2100">
+              <a:rPr sz="1700">
                 <a:solidFill>
                   <a:srgbClr val="111827"/>
                 </a:solidFill>
                 <a:latin typeface="Segoe UI"/>
               </a:rPr>
-              <a:t>3. Hallucination is structural; confidence ≠ truth</a:t>
+              <a:t>Prompt → Skill → Agent</a:t>
             </a:r>
           </a:p>
           <a:p>
@@ -6590,7 +6677,7 @@
               </a:spcAft>
             </a:pPr>
             <a:r>
-              <a:rPr sz="2100">
+              <a:rPr sz="1700">
                 <a:solidFill>
                   <a:srgbClr val="2563EB"/>
                 </a:solidFill>
@@ -6599,45 +6686,87 @@
               <a:t>▪  </a:t>
             </a:r>
             <a:r>
-              <a:rPr sz="2100">
+              <a:rPr sz="1700">
                 <a:solidFill>
                   <a:srgbClr val="111827"/>
                 </a:solidFill>
                 <a:latin typeface="Segoe UI"/>
               </a:rPr>
-              <a:t>4. Use where you can verify, or truth doesn't matter — own the output</a:t>
-            </a:r>
-          </a:p>
-          <a:p>
-            <a:pPr>
-              <a:spcAft>
-                <a:spcPts val="1400"/>
-              </a:spcAft>
-            </a:pPr>
-            <a:r>
-              <a:rPr sz="2100">
-                <a:solidFill>
-                  <a:srgbClr val="2563EB"/>
-                </a:solidFill>
-                <a:latin typeface="Segoe UI"/>
-              </a:rPr>
-              <a:t>▪  </a:t>
-            </a:r>
-            <a:r>
-              <a:rPr sz="2100">
-                <a:solidFill>
-                  <a:srgbClr val="111827"/>
-                </a:solidFill>
-                <a:latin typeface="Segoe UI"/>
-              </a:rPr>
-              <a:t>5. Good prompts are clear briefs, not magic words</a:t>
-            </a:r>
-          </a:p>
-        </p:txBody>
-      </p:sp>
-      <p:sp>
-        <p:nvSpPr>
-          <p:cNvPr id="5" name="TextBox 4"/>
+              <a:t>The catch: an agent acts on its output — so "own the output" matters MORE, not less</a:t>
+            </a:r>
+          </a:p>
+        </p:txBody>
+      </p:sp>
+      <p:sp>
+        <p:nvSpPr>
+          <p:cNvPr id="5" name="Rounded Rectangle 4" descr="Diagram: Next: when the model acts, not just answers"/>
+          <p:cNvSpPr/>
+          <p:nvPr/>
+        </p:nvSpPr>
+        <p:spPr>
+          <a:xfrm>
+            <a:off x="5943600" y="1554480"/>
+            <a:ext cx="5577840" cy="3840480"/>
+          </a:xfrm>
+          <a:prstGeom prst="roundRect">
+            <a:avLst/>
+          </a:prstGeom>
+          <a:solidFill>
+            <a:srgbClr val="F3F4F6"/>
+          </a:solidFill>
+          <a:ln w="12700">
+            <a:solidFill>
+              <a:srgbClr val="6B7280"/>
+            </a:solidFill>
+          </a:ln>
+          <a:effectLst/>
+        </p:spPr>
+        <p:style>
+          <a:lnRef idx="1">
+            <a:schemeClr val="accent1"/>
+          </a:lnRef>
+          <a:fillRef idx="3">
+            <a:schemeClr val="accent1"/>
+          </a:fillRef>
+          <a:effectRef idx="2">
+            <a:schemeClr val="accent1"/>
+          </a:effectRef>
+          <a:fontRef idx="minor">
+            <a:schemeClr val="lt1"/>
+          </a:fontRef>
+        </p:style>
+        <p:txBody>
+          <a:bodyPr rtlCol="0" anchor="ctr" wrap="square"/>
+          <a:lstStyle/>
+          <a:p>
+            <a:pPr algn="ctr"/>
+            <a:r>
+              <a:rPr sz="1300" b="1">
+                <a:solidFill>
+                  <a:srgbClr val="6B7280"/>
+                </a:solidFill>
+                <a:latin typeface="Segoe UI"/>
+              </a:rPr>
+              <a:t>DIAGRAM — render from Mermaid source (in speaker notes)</a:t>
+            </a:r>
+          </a:p>
+          <a:p>
+            <a:pPr algn="ctr"/>
+            <a:r>
+              <a:rPr sz="1500">
+                <a:solidFill>
+                  <a:srgbClr val="1F2A37"/>
+                </a:solidFill>
+                <a:latin typeface="Segoe UI"/>
+              </a:rPr>
+              <a:t>Prompt one-off instruction  →  Skill saved reusable procedure  →  Agent acts with tools in a loop</a:t>
+            </a:r>
+          </a:p>
+        </p:txBody>
+      </p:sp>
+      <p:sp>
+        <p:nvSpPr>
+          <p:cNvPr id="6" name="TextBox 5"/>
           <p:cNvSpPr txBox="1"/>
           <p:nvPr/>
         </p:nvSpPr>
@@ -6726,7 +6855,7 @@
                 </a:solidFill>
                 <a:latin typeface="Segoe UI"/>
               </a:rPr>
-              <a:t>Questions, and where to go next</a:t>
+              <a:t>Take away six things</a:t>
             </a:r>
           </a:p>
         </p:txBody>
@@ -6818,7 +6947,7 @@
                 </a:solidFill>
                 <a:latin typeface="Segoe UI"/>
               </a:rPr>
-              <a:t>Questions?</a:t>
+              <a:t>1. Learns from examples, not rules</a:t>
             </a:r>
           </a:p>
           <a:p>
@@ -6843,7 +6972,7 @@
                 </a:solidFill>
                 <a:latin typeface="Segoe UI"/>
               </a:rPr>
-              <a:t>Full 16-session course</a:t>
+              <a:t>2. Autocomplete on steroids — doesn't look things up</a:t>
             </a:r>
           </a:p>
           <a:p>
@@ -6868,7 +6997,320 @@
                 </a:solidFill>
                 <a:latin typeface="Segoe UI"/>
               </a:rPr>
-              <a:t>Start with: Session 1, Session 13 (confidently wrong), Sessions 10–11 (prompting)</a:t>
+              <a:t>3. Hallucination is structural; confidence ≠ truth</a:t>
+            </a:r>
+          </a:p>
+          <a:p>
+            <a:pPr>
+              <a:spcAft>
+                <a:spcPts val="1400"/>
+              </a:spcAft>
+            </a:pPr>
+            <a:r>
+              <a:rPr sz="2100">
+                <a:solidFill>
+                  <a:srgbClr val="2563EB"/>
+                </a:solidFill>
+                <a:latin typeface="Segoe UI"/>
+              </a:rPr>
+              <a:t>▪  </a:t>
+            </a:r>
+            <a:r>
+              <a:rPr sz="2100">
+                <a:solidFill>
+                  <a:srgbClr val="111827"/>
+                </a:solidFill>
+                <a:latin typeface="Segoe UI"/>
+              </a:rPr>
+              <a:t>4. Use where you can verify, or truth doesn't matter — own the output</a:t>
+            </a:r>
+          </a:p>
+          <a:p>
+            <a:pPr>
+              <a:spcAft>
+                <a:spcPts val="1400"/>
+              </a:spcAft>
+            </a:pPr>
+            <a:r>
+              <a:rPr sz="2100">
+                <a:solidFill>
+                  <a:srgbClr val="2563EB"/>
+                </a:solidFill>
+                <a:latin typeface="Segoe UI"/>
+              </a:rPr>
+              <a:t>▪  </a:t>
+            </a:r>
+            <a:r>
+              <a:rPr sz="2100">
+                <a:solidFill>
+                  <a:srgbClr val="111827"/>
+                </a:solidFill>
+                <a:latin typeface="Segoe UI"/>
+              </a:rPr>
+              <a:t>5. Good prompts are clear briefs, not magic words</a:t>
+            </a:r>
+          </a:p>
+          <a:p>
+            <a:pPr>
+              <a:spcAft>
+                <a:spcPts val="1400"/>
+              </a:spcAft>
+            </a:pPr>
+            <a:r>
+              <a:rPr sz="2100">
+                <a:solidFill>
+                  <a:srgbClr val="2563EB"/>
+                </a:solidFill>
+                <a:latin typeface="Segoe UI"/>
+              </a:rPr>
+              <a:t>▪  </a:t>
+            </a:r>
+            <a:r>
+              <a:rPr sz="2100">
+                <a:solidFill>
+                  <a:srgbClr val="111827"/>
+                </a:solidFill>
+                <a:latin typeface="Segoe UI"/>
+              </a:rPr>
+              <a:t>6. Agents act, skills make them consistent — owning the output matters more once it acts</a:t>
+            </a:r>
+          </a:p>
+        </p:txBody>
+      </p:sp>
+      <p:sp>
+        <p:nvSpPr>
+          <p:cNvPr id="5" name="TextBox 4"/>
+          <p:cNvSpPr txBox="1"/>
+          <p:nvPr/>
+        </p:nvSpPr>
+        <p:spPr>
+          <a:xfrm>
+            <a:off x="640080" y="6327648"/>
+            <a:ext cx="6858000" cy="365760"/>
+          </a:xfrm>
+          <a:prstGeom prst="rect">
+            <a:avLst/>
+          </a:prstGeom>
+          <a:noFill/>
+        </p:spPr>
+        <p:txBody>
+          <a:bodyPr wrap="square" anchor="t">
+            <a:spAutoFit/>
+          </a:bodyPr>
+          <a:lstStyle/>
+          <a:p>
+            <a:pPr algn="l">
+              <a:spcAft>
+                <a:spcPts val="1000"/>
+              </a:spcAft>
+            </a:pPr>
+            <a:r>
+              <a:rPr sz="1100" b="0">
+                <a:solidFill>
+                  <a:srgbClr val="6B7280"/>
+                </a:solidFill>
+                <a:latin typeface="Segoe UI"/>
+              </a:rPr>
+              <a:t>AI Training Series</a:t>
+            </a:r>
+          </a:p>
+        </p:txBody>
+      </p:sp>
+    </p:spTree>
+  </p:cSld>
+  <p:clrMapOvr>
+    <a:masterClrMapping/>
+  </p:clrMapOvr>
+</p:sld>
+</file>
+
+<file path=ppt/slides/slide17.xml><?xml version="1.0" encoding="utf-8"?>
+<p:sld xmlns:a="http://schemas.openxmlformats.org/drawingml/2006/main" xmlns:p="http://schemas.openxmlformats.org/presentationml/2006/main" xmlns:r="http://schemas.openxmlformats.org/officeDocument/2006/relationships">
+  <p:cSld>
+    <p:spTree>
+      <p:nvGrpSpPr>
+        <p:cNvPr id="1" name=""/>
+        <p:cNvGrpSpPr/>
+        <p:nvPr/>
+      </p:nvGrpSpPr>
+      <p:grpSpPr/>
+      <p:sp>
+        <p:nvSpPr>
+          <p:cNvPr id="2" name="TextBox 1"/>
+          <p:cNvSpPr txBox="1"/>
+          <p:nvPr/>
+        </p:nvSpPr>
+        <p:spPr>
+          <a:xfrm>
+            <a:off x="640080" y="502920"/>
+            <a:ext cx="10881360" cy="731520"/>
+          </a:xfrm>
+          <a:prstGeom prst="rect">
+            <a:avLst/>
+          </a:prstGeom>
+          <a:noFill/>
+        </p:spPr>
+        <p:txBody>
+          <a:bodyPr wrap="square" anchor="t">
+            <a:spAutoFit/>
+          </a:bodyPr>
+          <a:lstStyle/>
+          <a:p>
+            <a:pPr algn="l">
+              <a:spcAft>
+                <a:spcPts val="1000"/>
+              </a:spcAft>
+            </a:pPr>
+            <a:r>
+              <a:rPr sz="2800" b="1">
+                <a:solidFill>
+                  <a:srgbClr val="1F2A37"/>
+                </a:solidFill>
+                <a:latin typeface="Segoe UI"/>
+              </a:rPr>
+              <a:t>Questions, and where to go next</a:t>
+            </a:r>
+          </a:p>
+        </p:txBody>
+      </p:sp>
+      <p:sp>
+        <p:nvSpPr>
+          <p:cNvPr id="3" name="Rectangle 2"/>
+          <p:cNvSpPr/>
+          <p:nvPr/>
+        </p:nvSpPr>
+        <p:spPr>
+          <a:xfrm>
+            <a:off x="640080" y="1170432"/>
+            <a:ext cx="1005840" cy="50800"/>
+          </a:xfrm>
+          <a:prstGeom prst="rect">
+            <a:avLst/>
+          </a:prstGeom>
+          <a:solidFill>
+            <a:srgbClr val="2563EB"/>
+          </a:solidFill>
+          <a:ln>
+            <a:noFill/>
+          </a:ln>
+          <a:effectLst/>
+        </p:spPr>
+        <p:style>
+          <a:lnRef idx="1">
+            <a:schemeClr val="accent1"/>
+          </a:lnRef>
+          <a:fillRef idx="3">
+            <a:schemeClr val="accent1"/>
+          </a:fillRef>
+          <a:effectRef idx="2">
+            <a:schemeClr val="accent1"/>
+          </a:effectRef>
+          <a:fontRef idx="minor">
+            <a:schemeClr val="lt1"/>
+          </a:fontRef>
+        </p:style>
+        <p:txBody>
+          <a:bodyPr rtlCol="0" anchor="ctr"/>
+          <a:lstStyle/>
+          <a:p>
+            <a:pPr algn="ctr"/>
+          </a:p>
+        </p:txBody>
+      </p:sp>
+      <p:sp>
+        <p:nvSpPr>
+          <p:cNvPr id="4" name="TextBox 3"/>
+          <p:cNvSpPr txBox="1"/>
+          <p:nvPr/>
+        </p:nvSpPr>
+        <p:spPr>
+          <a:xfrm>
+            <a:off x="822960" y="1691640"/>
+            <a:ext cx="10424160" cy="4023360"/>
+          </a:xfrm>
+          <a:prstGeom prst="rect">
+            <a:avLst/>
+          </a:prstGeom>
+          <a:noFill/>
+        </p:spPr>
+        <p:txBody>
+          <a:bodyPr wrap="square">
+            <a:spAutoFit/>
+          </a:bodyPr>
+          <a:lstStyle/>
+          <a:p>
+            <a:pPr>
+              <a:spcAft>
+                <a:spcPts val="1400"/>
+              </a:spcAft>
+            </a:pPr>
+            <a:r>
+              <a:rPr sz="2100">
+                <a:solidFill>
+                  <a:srgbClr val="2563EB"/>
+                </a:solidFill>
+                <a:latin typeface="Segoe UI"/>
+              </a:rPr>
+              <a:t>▪  </a:t>
+            </a:r>
+            <a:r>
+              <a:rPr sz="2100">
+                <a:solidFill>
+                  <a:srgbClr val="111827"/>
+                </a:solidFill>
+                <a:latin typeface="Segoe UI"/>
+              </a:rPr>
+              <a:t>Questions?</a:t>
+            </a:r>
+          </a:p>
+          <a:p>
+            <a:pPr>
+              <a:spcAft>
+                <a:spcPts val="1400"/>
+              </a:spcAft>
+            </a:pPr>
+            <a:r>
+              <a:rPr sz="2100">
+                <a:solidFill>
+                  <a:srgbClr val="2563EB"/>
+                </a:solidFill>
+                <a:latin typeface="Segoe UI"/>
+              </a:rPr>
+              <a:t>▪  </a:t>
+            </a:r>
+            <a:r>
+              <a:rPr sz="2100">
+                <a:solidFill>
+                  <a:srgbClr val="111827"/>
+                </a:solidFill>
+                <a:latin typeface="Segoe UI"/>
+              </a:rPr>
+              <a:t>Full 16-session course</a:t>
+            </a:r>
+          </a:p>
+          <a:p>
+            <a:pPr>
+              <a:spcAft>
+                <a:spcPts val="1400"/>
+              </a:spcAft>
+            </a:pPr>
+            <a:r>
+              <a:rPr sz="2100">
+                <a:solidFill>
+                  <a:srgbClr val="2563EB"/>
+                </a:solidFill>
+                <a:latin typeface="Segoe UI"/>
+              </a:rPr>
+              <a:t>▪  </a:t>
+            </a:r>
+            <a:r>
+              <a:rPr sz="2100">
+                <a:solidFill>
+                  <a:srgbClr val="111827"/>
+                </a:solidFill>
+                <a:latin typeface="Segoe UI"/>
+              </a:rPr>
+              <a:t>Start with: Session 1, Session 13 (confidently wrong), Sessions 10–12 (prompting, Claude, agents)</a:t>
             </a:r>
           </a:p>
           <a:p>
@@ -7181,7 +7623,32 @@
                 </a:solidFill>
                 <a:latin typeface="Segoe UI"/>
               </a:rPr>
-              <a:t>How to write a good prompt</a:t>
+              <a:t>Good prompts</a:t>
+            </a:r>
+          </a:p>
+          <a:p>
+            <a:pPr>
+              <a:spcAft>
+                <a:spcPts val="1400"/>
+              </a:spcAft>
+            </a:pPr>
+            <a:r>
+              <a:rPr sz="1700">
+                <a:solidFill>
+                  <a:srgbClr val="2563EB"/>
+                </a:solidFill>
+                <a:latin typeface="Segoe UI"/>
+              </a:rPr>
+              <a:t>▪  </a:t>
+            </a:r>
+            <a:r>
+              <a:rPr sz="1700">
+                <a:solidFill>
+                  <a:srgbClr val="111827"/>
+                </a:solidFill>
+                <a:latin typeface="Segoe UI"/>
+              </a:rPr>
+              <a:t>Agents &amp; skills (what's next)</a:t>
             </a:r>
           </a:p>
         </p:txBody>
@@ -7248,7 +7715,7 @@
                 </a:solidFill>
                 <a:latin typeface="Segoe UI"/>
               </a:rPr>
-              <a:t>What AI is  →  How it works  →  Why it lies  →  Working with it  →  Good prompts</a:t>
+              <a:t>What AI is  →  How it works  →  Why it lies  →  Working with it  →  Good prompts  →  Agents &amp; skills</a:t>
             </a:r>
           </a:p>
         </p:txBody>

</xml_diff>

<commit_message>
Stretch the intro talk to 35 minutes; give agents and skills a slide each
Expanded the standalone overview from 30 to 35 minutes:
- Split the single agents/skills slide into two proper slides — one for
  agents (the Think-Act-Observe loop and the "acts on its output" safety
  flip) and one for skills (the prompt -> skill -> agent ladder,
  consistency). Agents were flagged as important; they now get real weight.
- Added a "daily do's and don'ts" slide, promoting the practical guidance
  that previously lived only in the reading into the deck.
- Rebudgeted the agenda to 35 min; deck is now 19 slides.
- Titles, intro, and agenda updated to 35 minutes.

Folder/file slug stays overview-30min (a stable identifier; the file was
open in the editor and renaming would break that path). All human-facing
content reads "35 minutes".

Co-Authored-By: Claude Opus 4.8 <noreply@anthropic.com>
</commit_message>
<xml_diff>
--- a/training/decks/overview-30min.pptx
+++ b/training/decks/overview-30min.pptx
@@ -22,6 +22,8 @@
     <p:sldId id="270" r:id="rId22"/>
     <p:sldId id="271" r:id="rId23"/>
     <p:sldId id="272" r:id="rId24"/>
+    <p:sldId id="273" r:id="rId25"/>
+    <p:sldId id="274" r:id="rId26"/>
   </p:sldIdLst>
   <p:sldSz cx="12191695" cy="6858000" type="screen4x3"/>
   <p:notesSz cx="6858000" cy="9144000"/>
@@ -764,7 +766,7 @@
           <a:lstStyle/>
           <a:p>
             <a:r>
-              <a:t>DEMO. Ask the model for a biography of a colleague (or yourself) who isn't famous. It will produce fluent, specific, confident, largely fabricated detail. Nothing lands "confident and wrong look identical" harder than watching it happen live. Fallback if no network: a pre-captured screenshot. Keep it light — the point is visceral, not a gotcha.</a:t>
+              <a:t>The practical heart of "how to work with it." Frame the do's as the sweet spot: transformation tasks where the material is in front of you and errors are visible. Frame the don'ts as the two ways people get burned — data leaving the building, and unverified facts going into something that matters. "Give it the source and ask it to work from that" is the single most useful habit; it makes the output checkable, which is the whole game. This slide is a keeper — tell them to photograph it.</a:t>
             </a:r>
           </a:p>
         </p:txBody>
@@ -834,23 +836,7 @@
           <a:lstStyle/>
           <a:p>
             <a:r>
-              <a:t>Reframe prompting as briefing, not incantation. The model is capable but knows nothing about your specific situation, so you supply that. Walk the five parts once. Emphasise that the biggest lever, by far, is specificity plus giving it the actual source material to work from.</a:t>
-            </a:r>
-          </a:p>
-          <a:p/>
-          <a:p>
-            <a:r>
-              <a:t>--- Mermaid source 1 (render and place on the diagram box) ---</a:t>
-            </a:r>
-          </a:p>
-          <a:p>
-            <a:r>
-              <a:t>flowchart TD</a:t>
-            </a:r>
-          </a:p>
-          <a:p>
-            <a:r>
-              <a:t>    R["Role"] --&gt; T["Task — one clear ask"] --&gt; C["Context + source material"] --&gt; F["Format"] --&gt; E["Example (if shape matters)"]</a:t>
+              <a:t>DEMO. Ask the model for a biography of a colleague (or yourself) who isn't famous. It will produce fluent, specific, confident, largely fabricated detail. Nothing lands "confident and wrong look identical" harder than watching it happen live. Fallback if no network: a pre-captured screenshot. Keep it light — the point is visceral, not a gotcha.</a:t>
             </a:r>
           </a:p>
         </p:txBody>
@@ -920,7 +906,23 @@
           <a:lstStyle/>
           <a:p>
             <a:r>
-              <a:t>The money slide for the prompting section. Read both aloud. The "after" wins on specificity, real source material (which makes the output checkable), and an explicit "don't invent" instruction. It quietly demonstrates the safety habits too. Then the honest anti-pattern: there is no magic phrase — "act as a world-class expert" does far less than one concrete example.</a:t>
+              <a:t>Reframe prompting as briefing, not incantation. The model is capable but knows nothing about your specific situation, so you supply that. Walk the five parts once. Emphasise that the biggest lever, by far, is specificity plus giving it the actual source material to work from.</a:t>
+            </a:r>
+          </a:p>
+          <a:p/>
+          <a:p>
+            <a:r>
+              <a:t>--- Mermaid source 1 (render and place on the diagram box) ---</a:t>
+            </a:r>
+          </a:p>
+          <a:p>
+            <a:r>
+              <a:t>flowchart TD</a:t>
+            </a:r>
+          </a:p>
+          <a:p>
+            <a:r>
+              <a:t>    R["Role"] --&gt; T["Task — one clear ask"] --&gt; C["Context + source material"] --&gt; F["Format"] --&gt; E["Example (if shape matters)"]</a:t>
             </a:r>
           </a:p>
         </p:txBody>
@@ -990,23 +992,7 @@
           <a:lstStyle/>
           <a:p>
             <a:r>
-              <a:t>This is the "where it's going" slide, and it was flagged as important — give it real weight. An agent doesn't just reply; it uses tools in a Think–Act–Observe loop until the job is done. A skill is a written procedure the model reuses, so it is consistent and expert at YOUR tasks rather than generically capable. Walk the prompt→skill→agent ladder. Then the safety line, which is the whole point: a wrong chatbot answer is an embarrassment you catch on reading; a wrong answer from an agent that already filed the ticket or ran the command is an incident. Start narrow, keep a human gate. The full course goes deep — Sessions 11 (skills, MCP, working with Claude) and 12 (agents).</a:t>
-            </a:r>
-          </a:p>
-          <a:p/>
-          <a:p>
-            <a:r>
-              <a:t>--- Mermaid source 1 (render and place on the diagram box) ---</a:t>
-            </a:r>
-          </a:p>
-          <a:p>
-            <a:r>
-              <a:t>flowchart LR</a:t>
-            </a:r>
-          </a:p>
-          <a:p>
-            <a:r>
-              <a:t>    P["Prompt&lt;br/&gt;one-off instruction"] --&gt; S["Skill&lt;br/&gt;saved reusable procedure"] --&gt; A["Agent&lt;br/&gt;acts with tools in a loop"]</a:t>
+              <a:t>The money slide for the prompting section. Read both aloud. The "after" wins on specificity, real source material (which makes the output checkable), and an explicit "don't invent" instruction. It quietly demonstrates the safety habits too. Then the honest anti-pattern: there is no magic phrase — "act as a world-class expert" does far less than one concrete example.</a:t>
             </a:r>
           </a:p>
         </p:txBody>
@@ -1076,7 +1062,43 @@
           <a:lstStyle/>
           <a:p>
             <a:r>
-              <a:t>Recap the arc. Then the one sentence to leave in the room: an LLM is a fluent, confident, sometimes-wrong assistant — brilliant when you can check its work, dangerous when you can't. Treat it accordingly, especially once you let it act. Point to the full course for anyone who wants more.</a:t>
+              <a:t>Agents were flagged as important, so give them a full slide. The shift is from a model that answers to one that acts. Walk the Think–Act–Observe loop concretely with a task from this room — e.g. "read the failed pipeline log, find the likely cause, and open a draft ticket." Genuinely powerful. Then land the safety point hard, because it's the whole reason it matters: a wrong chatbot answer is caught when you read it; a wrong answer from an agent that already ran the command or filed the ticket is an incident. So everything from the "own the output" rule matters more with agents, not less. Start them on narrow, well-bounded tasks with a human gate.</a:t>
+            </a:r>
+          </a:p>
+          <a:p/>
+          <a:p>
+            <a:r>
+              <a:t>--- Mermaid source 1 (render and place on the diagram box) ---</a:t>
+            </a:r>
+          </a:p>
+          <a:p>
+            <a:r>
+              <a:t>flowchart LR</a:t>
+            </a:r>
+          </a:p>
+          <a:p>
+            <a:r>
+              <a:t>    G["Goal"] --&gt; TH["Think:&lt;br/&gt;next step?"]</a:t>
+            </a:r>
+          </a:p>
+          <a:p>
+            <a:r>
+              <a:t>    TH --&gt; AC["Act:&lt;br/&gt;use a tool"]</a:t>
+            </a:r>
+          </a:p>
+          <a:p>
+            <a:r>
+              <a:t>    AC --&gt; OB["Observe:&lt;br/&gt;read result"]</a:t>
+            </a:r>
+          </a:p>
+          <a:p>
+            <a:r>
+              <a:t>    OB --&gt; TH</a:t>
+            </a:r>
+          </a:p>
+          <a:p>
+            <a:r>
+              <a:t>    OB --&gt; D["Done"]</a:t>
             </a:r>
           </a:p>
         </p:txBody>
@@ -1146,6 +1168,162 @@
           <a:lstStyle/>
           <a:p>
             <a:r>
+              <a:t>The complement to agents. A prompt is one-off; you re-explain every time. A skill is a saved procedure — "here's exactly how we write release notes / triage an incident" — that the model loads whenever it's relevant. That's what turns a generically capable model into one that does your tasks your way, and it's what makes an agent reliable rather than improvisational. Walk the ladder: prompt is asking a colleague one thing; a skill is the team's how-to guide they follow every time; an agent is delegating a whole task. For an intro, the takeaway is awareness — agents and skills are how AI moves from answering questions to doing tasks. Sessions 11 (skills, working with Claude) and 12 (agents) go deep.</a:t>
+            </a:r>
+          </a:p>
+          <a:p/>
+          <a:p>
+            <a:r>
+              <a:t>--- Mermaid source 1 (render and place on the diagram box) ---</a:t>
+            </a:r>
+          </a:p>
+          <a:p>
+            <a:r>
+              <a:t>flowchart LR</a:t>
+            </a:r>
+          </a:p>
+          <a:p>
+            <a:r>
+              <a:t>    P["Prompt&lt;br/&gt;one-off instruction"] --&gt; S["Skill&lt;br/&gt;saved reusable procedure"] --&gt; A["Agent&lt;br/&gt;acts with tools in a loop"]</a:t>
+            </a:r>
+          </a:p>
+        </p:txBody>
+      </p:sp>
+      <p:sp>
+        <p:nvSpPr>
+          <p:cNvPr id="4" name="Slide Number Placeholder 3"/>
+          <p:cNvSpPr>
+            <a:spLocks noGrp="1"/>
+          </p:cNvSpPr>
+          <p:nvPr>
+            <p:ph type="sldNum" idx="5" sz="quarter"/>
+          </p:nvPr>
+        </p:nvSpPr>
+        <p:spPr/>
+      </p:sp>
+    </p:spTree>
+  </p:cSld>
+  <p:clrMapOvr>
+    <a:masterClrMapping/>
+  </p:clrMapOvr>
+</p:notes>
+</file>
+
+<file path=ppt/notesSlides/notesSlide18.xml><?xml version="1.0" encoding="utf-8"?>
+<p:notes xmlns:a="http://schemas.openxmlformats.org/drawingml/2006/main" xmlns:p="http://schemas.openxmlformats.org/presentationml/2006/main" xmlns:r="http://schemas.openxmlformats.org/officeDocument/2006/relationships">
+  <p:cSld>
+    <p:spTree>
+      <p:nvGrpSpPr>
+        <p:cNvPr id="1" name=""/>
+        <p:cNvGrpSpPr/>
+        <p:nvPr/>
+      </p:nvGrpSpPr>
+      <p:grpSpPr>
+        <a:xfrm>
+          <a:off x="0" y="0"/>
+          <a:ext cx="0" cy="0"/>
+          <a:chOff x="0" y="0"/>
+          <a:chExt cx="0" cy="0"/>
+        </a:xfrm>
+      </p:grpSpPr>
+      <p:sp>
+        <p:nvSpPr>
+          <p:cNvPr id="2" name="Slide Image Placeholder 1"/>
+          <p:cNvSpPr>
+            <a:spLocks noGrp="1"/>
+          </p:cNvSpPr>
+          <p:nvPr>
+            <p:ph type="sldImg" idx="2"/>
+          </p:nvPr>
+        </p:nvSpPr>
+        <p:spPr/>
+      </p:sp>
+      <p:sp>
+        <p:nvSpPr>
+          <p:cNvPr id="3" name="Notes Placeholder 2"/>
+          <p:cNvSpPr>
+            <a:spLocks noGrp="1"/>
+          </p:cNvSpPr>
+          <p:nvPr>
+            <p:ph type="body" idx="3" sz="quarter"/>
+          </p:nvPr>
+        </p:nvSpPr>
+        <p:spPr/>
+        <p:txBody>
+          <a:bodyPr/>
+          <a:lstStyle/>
+          <a:p>
+            <a:r>
+              <a:t>Recap the arc. Then the one sentence to leave in the room: an LLM is a fluent, confident, sometimes-wrong assistant — brilliant when you can check its work, dangerous when you can't. Treat it accordingly, especially once you let it act. Point to the full course for anyone who wants more.</a:t>
+            </a:r>
+          </a:p>
+        </p:txBody>
+      </p:sp>
+      <p:sp>
+        <p:nvSpPr>
+          <p:cNvPr id="4" name="Slide Number Placeholder 3"/>
+          <p:cNvSpPr>
+            <a:spLocks noGrp="1"/>
+          </p:cNvSpPr>
+          <p:nvPr>
+            <p:ph type="sldNum" idx="5" sz="quarter"/>
+          </p:nvPr>
+        </p:nvSpPr>
+        <p:spPr/>
+      </p:sp>
+    </p:spTree>
+  </p:cSld>
+  <p:clrMapOvr>
+    <a:masterClrMapping/>
+  </p:clrMapOvr>
+</p:notes>
+</file>
+
+<file path=ppt/notesSlides/notesSlide19.xml><?xml version="1.0" encoding="utf-8"?>
+<p:notes xmlns:a="http://schemas.openxmlformats.org/drawingml/2006/main" xmlns:p="http://schemas.openxmlformats.org/presentationml/2006/main" xmlns:r="http://schemas.openxmlformats.org/officeDocument/2006/relationships">
+  <p:cSld>
+    <p:spTree>
+      <p:nvGrpSpPr>
+        <p:cNvPr id="1" name=""/>
+        <p:cNvGrpSpPr/>
+        <p:nvPr/>
+      </p:nvGrpSpPr>
+      <p:grpSpPr>
+        <a:xfrm>
+          <a:off x="0" y="0"/>
+          <a:ext cx="0" cy="0"/>
+          <a:chOff x="0" y="0"/>
+          <a:chExt cx="0" cy="0"/>
+        </a:xfrm>
+      </p:grpSpPr>
+      <p:sp>
+        <p:nvSpPr>
+          <p:cNvPr id="2" name="Slide Image Placeholder 1"/>
+          <p:cNvSpPr>
+            <a:spLocks noGrp="1"/>
+          </p:cNvSpPr>
+          <p:nvPr>
+            <p:ph type="sldImg" idx="2"/>
+          </p:nvPr>
+        </p:nvSpPr>
+        <p:spPr/>
+      </p:sp>
+      <p:sp>
+        <p:nvSpPr>
+          <p:cNvPr id="3" name="Notes Placeholder 2"/>
+          <p:cNvSpPr>
+            <a:spLocks noGrp="1"/>
+          </p:cNvSpPr>
+          <p:nvPr>
+            <p:ph type="body" idx="3" sz="quarter"/>
+          </p:nvPr>
+        </p:nvSpPr>
+        <p:spPr/>
+        <p:txBody>
+          <a:bodyPr/>
+          <a:lstStyle/>
+          <a:p>
+            <a:r>
               <a:t>Open the floor. Common questions to expect: is our data safe to paste (depends — treat as external), will it replace jobs (see Session 15), which tool is best (they're similar; the skill transfers), can it just do the task for me (that's agents — Session 12). Point to the glossary and the full series.</a:t>
             </a:r>
           </a:p>
@@ -1216,7 +1394,7 @@
           <a:lstStyle/>
           <a:p>
             <a:r>
-              <a:t>Six beats, each builds on the last. Flag that beat three — why it makes things up — is the one that changes how you use these tools; beats four and five are the practical payoff; beat six is where the field is heading and was specifically asked for. Keep the pace up — this is 30 minutes, not 45.</a:t>
+              <a:t>Six beats, each builds on the last. Flag that beat three — why it makes things up — is the one that changes how you use these tools; beats four and five are the practical payoff; beat six is where the field is heading and was specifically asked for. Keep the pace up — this is 35 minutes, not 45.</a:t>
             </a:r>
           </a:p>
           <a:p/>
@@ -4881,7 +5059,7 @@
                 </a:solidFill>
                 <a:latin typeface="Segoe UI"/>
               </a:rPr>
-              <a:t>AI in 30 Minutes</a:t>
+              <a:t>AI in 35 Minutes</a:t>
             </a:r>
           </a:p>
         </p:txBody>
@@ -5630,7 +5808,7 @@
                 </a:solidFill>
                 <a:latin typeface="Segoe UI"/>
               </a:rPr>
-              <a:t>See it happen (live demo)</a:t>
+              <a:t>Daily do's and don'ts</a:t>
             </a:r>
           </a:p>
         </p:txBody>
@@ -5722,7 +5900,7 @@
                 </a:solidFill>
                 <a:latin typeface="Segoe UI"/>
               </a:rPr>
-              <a:t>Live: ask it for a short bio of someone in the room</a:t>
+              <a:t>DO: draft, summarise, rephrase, explain, get unstuck</a:t>
             </a:r>
           </a:p>
           <a:p>
@@ -5747,7 +5925,7 @@
                 </a:solidFill>
                 <a:latin typeface="Segoe UI"/>
               </a:rPr>
-              <a:t>Watch it invent plausible, specific, wrong details</a:t>
+              <a:t>DO: give it the source and ask it to work from THAT</a:t>
             </a:r>
           </a:p>
           <a:p>
@@ -5772,7 +5950,32 @@
                 </a:solidFill>
                 <a:latin typeface="Segoe UI"/>
               </a:rPr>
-              <a:t>Confidence unchanged throughout</a:t>
+              <a:t>DON'T: paste confidential or personal data</a:t>
+            </a:r>
+          </a:p>
+          <a:p>
+            <a:pPr>
+              <a:spcAft>
+                <a:spcPts val="1400"/>
+              </a:spcAft>
+            </a:pPr>
+            <a:r>
+              <a:rPr sz="2100">
+                <a:solidFill>
+                  <a:srgbClr val="2563EB"/>
+                </a:solidFill>
+                <a:latin typeface="Segoe UI"/>
+              </a:rPr>
+              <a:t>▪  </a:t>
+            </a:r>
+            <a:r>
+              <a:rPr sz="2100">
+                <a:solidFill>
+                  <a:srgbClr val="111827"/>
+                </a:solidFill>
+                <a:latin typeface="Segoe UI"/>
+              </a:rPr>
+              <a:t>DON'T: trust a fact, number, quote or citation unchecked</a:t>
             </a:r>
           </a:p>
         </p:txBody>
@@ -5812,45 +6015,6 @@
                 <a:latin typeface="Segoe UI"/>
               </a:rPr>
               <a:t>AI Training Series</a:t>
-            </a:r>
-          </a:p>
-        </p:txBody>
-      </p:sp>
-      <p:sp>
-        <p:nvSpPr>
-          <p:cNvPr id="6" name="TextBox 5"/>
-          <p:cNvSpPr txBox="1"/>
-          <p:nvPr/>
-        </p:nvSpPr>
-        <p:spPr>
-          <a:xfrm>
-            <a:off x="7498079" y="6327648"/>
-            <a:ext cx="4023360" cy="365760"/>
-          </a:xfrm>
-          <a:prstGeom prst="rect">
-            <a:avLst/>
-          </a:prstGeom>
-          <a:noFill/>
-        </p:spPr>
-        <p:txBody>
-          <a:bodyPr wrap="square" anchor="t">
-            <a:spAutoFit/>
-          </a:bodyPr>
-          <a:lstStyle/>
-          <a:p>
-            <a:pPr algn="r">
-              <a:spcAft>
-                <a:spcPts val="1000"/>
-              </a:spcAft>
-            </a:pPr>
-            <a:r>
-              <a:rPr sz="1000" b="0">
-                <a:solidFill>
-                  <a:srgbClr val="6B7280"/>
-                </a:solidFill>
-                <a:latin typeface="Segoe UI"/>
-              </a:rPr>
-              <a:t>live demo — nothing embedded.</a:t>
             </a:r>
           </a:p>
         </p:txBody>
@@ -5907,7 +6071,7 @@
                 </a:solidFill>
                 <a:latin typeface="Segoe UI"/>
               </a:rPr>
-              <a:t>Good output starts with a good brief</a:t>
+              <a:t>See it happen (live demo)</a:t>
             </a:r>
           </a:p>
         </p:txBody>
@@ -5964,8 +6128,8 @@
         </p:nvSpPr>
         <p:spPr>
           <a:xfrm>
-            <a:off x="640080" y="1463040"/>
-            <a:ext cx="4937760" cy="4206240"/>
+            <a:off x="822960" y="1691640"/>
+            <a:ext cx="10424160" cy="4023360"/>
           </a:xfrm>
           <a:prstGeom prst="rect">
             <a:avLst/>
@@ -5984,7 +6148,7 @@
               </a:spcAft>
             </a:pPr>
             <a:r>
-              <a:rPr sz="1700">
+              <a:rPr sz="2100">
                 <a:solidFill>
                   <a:srgbClr val="2563EB"/>
                 </a:solidFill>
@@ -5993,13 +6157,13 @@
               <a:t>▪  </a:t>
             </a:r>
             <a:r>
-              <a:rPr sz="1700">
+              <a:rPr sz="2100">
                 <a:solidFill>
                   <a:srgbClr val="111827"/>
                 </a:solidFill>
                 <a:latin typeface="Segoe UI"/>
               </a:rPr>
-              <a:t>Most bad output is a prompt problem, not a model problem</a:t>
+              <a:t>Live: ask it for a short bio of someone in the room</a:t>
             </a:r>
           </a:p>
           <a:p>
@@ -6009,7 +6173,7 @@
               </a:spcAft>
             </a:pPr>
             <a:r>
-              <a:rPr sz="1700">
+              <a:rPr sz="2100">
                 <a:solidFill>
                   <a:srgbClr val="2563EB"/>
                 </a:solidFill>
@@ -6018,13 +6182,13 @@
               <a:t>▪  </a:t>
             </a:r>
             <a:r>
-              <a:rPr sz="1700">
+              <a:rPr sz="2100">
                 <a:solidFill>
                   <a:srgbClr val="111827"/>
                 </a:solidFill>
                 <a:latin typeface="Segoe UI"/>
               </a:rPr>
-              <a:t>Brief it like a fast, well-read new colleague with no context</a:t>
+              <a:t>Watch it invent plausible, specific, wrong details</a:t>
             </a:r>
           </a:p>
           <a:p>
@@ -6034,7 +6198,7 @@
               </a:spcAft>
             </a:pPr>
             <a:r>
-              <a:rPr sz="1700">
+              <a:rPr sz="2100">
                 <a:solidFill>
                   <a:srgbClr val="2563EB"/>
                 </a:solidFill>
@@ -6043,162 +6207,20 @@
               <a:t>▪  </a:t>
             </a:r>
             <a:r>
-              <a:rPr sz="1700">
+              <a:rPr sz="2100">
                 <a:solidFill>
                   <a:srgbClr val="111827"/>
                 </a:solidFill>
                 <a:latin typeface="Segoe UI"/>
               </a:rPr>
-              <a:t>Role</a:t>
-            </a:r>
-          </a:p>
-          <a:p>
-            <a:pPr>
-              <a:spcAft>
-                <a:spcPts val="1400"/>
-              </a:spcAft>
-            </a:pPr>
-            <a:r>
-              <a:rPr sz="1700">
-                <a:solidFill>
-                  <a:srgbClr val="2563EB"/>
-                </a:solidFill>
-                <a:latin typeface="Segoe UI"/>
-              </a:rPr>
-              <a:t>▪  </a:t>
-            </a:r>
-            <a:r>
-              <a:rPr sz="1700">
-                <a:solidFill>
-                  <a:srgbClr val="111827"/>
-                </a:solidFill>
-                <a:latin typeface="Segoe UI"/>
-              </a:rPr>
-              <a:t>Task</a:t>
-            </a:r>
-          </a:p>
-          <a:p>
-            <a:pPr>
-              <a:spcAft>
-                <a:spcPts val="1400"/>
-              </a:spcAft>
-            </a:pPr>
-            <a:r>
-              <a:rPr sz="1700">
-                <a:solidFill>
-                  <a:srgbClr val="2563EB"/>
-                </a:solidFill>
-                <a:latin typeface="Segoe UI"/>
-              </a:rPr>
-              <a:t>▪  </a:t>
-            </a:r>
-            <a:r>
-              <a:rPr sz="1700">
-                <a:solidFill>
-                  <a:srgbClr val="111827"/>
-                </a:solidFill>
-                <a:latin typeface="Segoe UI"/>
-              </a:rPr>
-              <a:t>Context</a:t>
-            </a:r>
-          </a:p>
-          <a:p>
-            <a:pPr>
-              <a:spcAft>
-                <a:spcPts val="1400"/>
-              </a:spcAft>
-            </a:pPr>
-            <a:r>
-              <a:rPr sz="1700">
-                <a:solidFill>
-                  <a:srgbClr val="2563EB"/>
-                </a:solidFill>
-                <a:latin typeface="Segoe UI"/>
-              </a:rPr>
-              <a:t>▪  </a:t>
-            </a:r>
-            <a:r>
-              <a:rPr sz="1700">
-                <a:solidFill>
-                  <a:srgbClr val="111827"/>
-                </a:solidFill>
-                <a:latin typeface="Segoe UI"/>
-              </a:rPr>
-              <a:t>Format</a:t>
-            </a:r>
-          </a:p>
-        </p:txBody>
-      </p:sp>
-      <p:sp>
-        <p:nvSpPr>
-          <p:cNvPr id="5" name="Rounded Rectangle 4" descr="Diagram: Good output starts with a good brief"/>
-          <p:cNvSpPr/>
-          <p:nvPr/>
-        </p:nvSpPr>
-        <p:spPr>
-          <a:xfrm>
-            <a:off x="5943600" y="1554480"/>
-            <a:ext cx="5577840" cy="3840480"/>
-          </a:xfrm>
-          <a:prstGeom prst="roundRect">
-            <a:avLst/>
-          </a:prstGeom>
-          <a:solidFill>
-            <a:srgbClr val="F3F4F6"/>
-          </a:solidFill>
-          <a:ln w="12700">
-            <a:solidFill>
-              <a:srgbClr val="6B7280"/>
-            </a:solidFill>
-          </a:ln>
-          <a:effectLst/>
-        </p:spPr>
-        <p:style>
-          <a:lnRef idx="1">
-            <a:schemeClr val="accent1"/>
-          </a:lnRef>
-          <a:fillRef idx="3">
-            <a:schemeClr val="accent1"/>
-          </a:fillRef>
-          <a:effectRef idx="2">
-            <a:schemeClr val="accent1"/>
-          </a:effectRef>
-          <a:fontRef idx="minor">
-            <a:schemeClr val="lt1"/>
-          </a:fontRef>
-        </p:style>
-        <p:txBody>
-          <a:bodyPr rtlCol="0" anchor="ctr" wrap="square"/>
-          <a:lstStyle/>
-          <a:p>
-            <a:pPr algn="ctr"/>
-            <a:r>
-              <a:rPr sz="1300" b="1">
-                <a:solidFill>
-                  <a:srgbClr val="6B7280"/>
-                </a:solidFill>
-                <a:latin typeface="Segoe UI"/>
-              </a:rPr>
-              <a:t>DIAGRAM — render from Mermaid source (in speaker notes)</a:t>
-            </a:r>
-          </a:p>
-          <a:p>
-            <a:pPr algn="ctr"/>
-            <a:r>
-              <a:rPr sz="1500">
-                <a:solidFill>
-                  <a:srgbClr val="1F2A37"/>
-                </a:solidFill>
-                <a:latin typeface="Segoe UI"/>
-              </a:rPr>
-              <a:t>Role  →  Task — one clear ask  →  Context + source material  →  Format  →  Example (if shape matters)</a:t>
-            </a:r>
-          </a:p>
-        </p:txBody>
-      </p:sp>
-      <p:sp>
-        <p:nvSpPr>
-          <p:cNvPr id="6" name="TextBox 5"/>
+              <a:t>Confidence unchanged throughout</a:t>
+            </a:r>
+          </a:p>
+        </p:txBody>
+      </p:sp>
+      <p:sp>
+        <p:nvSpPr>
+          <p:cNvPr id="5" name="TextBox 4"/>
           <p:cNvSpPr txBox="1"/>
           <p:nvPr/>
         </p:nvSpPr>
@@ -6231,6 +6253,45 @@
                 <a:latin typeface="Segoe UI"/>
               </a:rPr>
               <a:t>AI Training Series</a:t>
+            </a:r>
+          </a:p>
+        </p:txBody>
+      </p:sp>
+      <p:sp>
+        <p:nvSpPr>
+          <p:cNvPr id="6" name="TextBox 5"/>
+          <p:cNvSpPr txBox="1"/>
+          <p:nvPr/>
+        </p:nvSpPr>
+        <p:spPr>
+          <a:xfrm>
+            <a:off x="7498079" y="6327648"/>
+            <a:ext cx="4023360" cy="365760"/>
+          </a:xfrm>
+          <a:prstGeom prst="rect">
+            <a:avLst/>
+          </a:prstGeom>
+          <a:noFill/>
+        </p:spPr>
+        <p:txBody>
+          <a:bodyPr wrap="square" anchor="t">
+            <a:spAutoFit/>
+          </a:bodyPr>
+          <a:lstStyle/>
+          <a:p>
+            <a:pPr algn="r">
+              <a:spcAft>
+                <a:spcPts val="1000"/>
+              </a:spcAft>
+            </a:pPr>
+            <a:r>
+              <a:rPr sz="1000" b="0">
+                <a:solidFill>
+                  <a:srgbClr val="6B7280"/>
+                </a:solidFill>
+                <a:latin typeface="Segoe UI"/>
+              </a:rPr>
+              <a:t>live demo — nothing embedded.</a:t>
             </a:r>
           </a:p>
         </p:txBody>
@@ -6287,7 +6348,7 @@
                 </a:solidFill>
                 <a:latin typeface="Segoe UI"/>
               </a:rPr>
-              <a:t>Before and after</a:t>
+              <a:t>Good output starts with a good brief</a:t>
             </a:r>
           </a:p>
         </p:txBody>
@@ -6344,8 +6405,8 @@
         </p:nvSpPr>
         <p:spPr>
           <a:xfrm>
-            <a:off x="822960" y="1691640"/>
-            <a:ext cx="10424160" cy="4023360"/>
+            <a:off x="640080" y="1463040"/>
+            <a:ext cx="4937760" cy="4206240"/>
           </a:xfrm>
           <a:prstGeom prst="rect">
             <a:avLst/>
@@ -6364,7 +6425,7 @@
               </a:spcAft>
             </a:pPr>
             <a:r>
-              <a:rPr sz="2100">
+              <a:rPr sz="1700">
                 <a:solidFill>
                   <a:srgbClr val="2563EB"/>
                 </a:solidFill>
@@ -6373,13 +6434,13 @@
               <a:t>▪  </a:t>
             </a:r>
             <a:r>
-              <a:rPr sz="2100">
+              <a:rPr sz="1700">
                 <a:solidFill>
                   <a:srgbClr val="111827"/>
                 </a:solidFill>
                 <a:latin typeface="Segoe UI"/>
               </a:rPr>
-              <a:t>Before: "Write release notes." → invents audience, format, and content</a:t>
+              <a:t>Most bad output is a prompt problem, not a model problem</a:t>
             </a:r>
           </a:p>
           <a:p>
@@ -6389,7 +6450,7 @@
               </a:spcAft>
             </a:pPr>
             <a:r>
-              <a:rPr sz="2100">
+              <a:rPr sz="1700">
                 <a:solidFill>
                   <a:srgbClr val="2563EB"/>
                 </a:solidFill>
@@ -6398,13 +6459,13 @@
               <a:t>▪  </a:t>
             </a:r>
             <a:r>
-              <a:rPr sz="2100">
+              <a:rPr sz="1700">
                 <a:solidFill>
                   <a:srgbClr val="111827"/>
                 </a:solidFill>
                 <a:latin typeface="Segoe UI"/>
               </a:rPr>
-              <a:t>After: role + the 12 real PR titles + "group into Features/Fixes/Known Issues, one sentence each, invent nothing"</a:t>
+              <a:t>Brief it like a fast, well-read new colleague with no context</a:t>
             </a:r>
           </a:p>
           <a:p>
@@ -6414,7 +6475,7 @@
               </a:spcAft>
             </a:pPr>
             <a:r>
-              <a:rPr sz="2100">
+              <a:rPr sz="1700">
                 <a:solidFill>
                   <a:srgbClr val="2563EB"/>
                 </a:solidFill>
@@ -6423,20 +6484,162 @@
               <a:t>▪  </a:t>
             </a:r>
             <a:r>
-              <a:rPr sz="2100">
+              <a:rPr sz="1700">
                 <a:solidFill>
                   <a:srgbClr val="111827"/>
                 </a:solidFill>
                 <a:latin typeface="Segoe UI"/>
               </a:rPr>
-              <a:t>Same model. Completely different result</a:t>
-            </a:r>
-          </a:p>
-        </p:txBody>
-      </p:sp>
-      <p:sp>
-        <p:nvSpPr>
-          <p:cNvPr id="5" name="TextBox 4"/>
+              <a:t>Role</a:t>
+            </a:r>
+          </a:p>
+          <a:p>
+            <a:pPr>
+              <a:spcAft>
+                <a:spcPts val="1400"/>
+              </a:spcAft>
+            </a:pPr>
+            <a:r>
+              <a:rPr sz="1700">
+                <a:solidFill>
+                  <a:srgbClr val="2563EB"/>
+                </a:solidFill>
+                <a:latin typeface="Segoe UI"/>
+              </a:rPr>
+              <a:t>▪  </a:t>
+            </a:r>
+            <a:r>
+              <a:rPr sz="1700">
+                <a:solidFill>
+                  <a:srgbClr val="111827"/>
+                </a:solidFill>
+                <a:latin typeface="Segoe UI"/>
+              </a:rPr>
+              <a:t>Task</a:t>
+            </a:r>
+          </a:p>
+          <a:p>
+            <a:pPr>
+              <a:spcAft>
+                <a:spcPts val="1400"/>
+              </a:spcAft>
+            </a:pPr>
+            <a:r>
+              <a:rPr sz="1700">
+                <a:solidFill>
+                  <a:srgbClr val="2563EB"/>
+                </a:solidFill>
+                <a:latin typeface="Segoe UI"/>
+              </a:rPr>
+              <a:t>▪  </a:t>
+            </a:r>
+            <a:r>
+              <a:rPr sz="1700">
+                <a:solidFill>
+                  <a:srgbClr val="111827"/>
+                </a:solidFill>
+                <a:latin typeface="Segoe UI"/>
+              </a:rPr>
+              <a:t>Context</a:t>
+            </a:r>
+          </a:p>
+          <a:p>
+            <a:pPr>
+              <a:spcAft>
+                <a:spcPts val="1400"/>
+              </a:spcAft>
+            </a:pPr>
+            <a:r>
+              <a:rPr sz="1700">
+                <a:solidFill>
+                  <a:srgbClr val="2563EB"/>
+                </a:solidFill>
+                <a:latin typeface="Segoe UI"/>
+              </a:rPr>
+              <a:t>▪  </a:t>
+            </a:r>
+            <a:r>
+              <a:rPr sz="1700">
+                <a:solidFill>
+                  <a:srgbClr val="111827"/>
+                </a:solidFill>
+                <a:latin typeface="Segoe UI"/>
+              </a:rPr>
+              <a:t>Format</a:t>
+            </a:r>
+          </a:p>
+        </p:txBody>
+      </p:sp>
+      <p:sp>
+        <p:nvSpPr>
+          <p:cNvPr id="5" name="Rounded Rectangle 4" descr="Diagram: Good output starts with a good brief"/>
+          <p:cNvSpPr/>
+          <p:nvPr/>
+        </p:nvSpPr>
+        <p:spPr>
+          <a:xfrm>
+            <a:off x="5943600" y="1554480"/>
+            <a:ext cx="5577840" cy="3840480"/>
+          </a:xfrm>
+          <a:prstGeom prst="roundRect">
+            <a:avLst/>
+          </a:prstGeom>
+          <a:solidFill>
+            <a:srgbClr val="F3F4F6"/>
+          </a:solidFill>
+          <a:ln w="12700">
+            <a:solidFill>
+              <a:srgbClr val="6B7280"/>
+            </a:solidFill>
+          </a:ln>
+          <a:effectLst/>
+        </p:spPr>
+        <p:style>
+          <a:lnRef idx="1">
+            <a:schemeClr val="accent1"/>
+          </a:lnRef>
+          <a:fillRef idx="3">
+            <a:schemeClr val="accent1"/>
+          </a:fillRef>
+          <a:effectRef idx="2">
+            <a:schemeClr val="accent1"/>
+          </a:effectRef>
+          <a:fontRef idx="minor">
+            <a:schemeClr val="lt1"/>
+          </a:fontRef>
+        </p:style>
+        <p:txBody>
+          <a:bodyPr rtlCol="0" anchor="ctr" wrap="square"/>
+          <a:lstStyle/>
+          <a:p>
+            <a:pPr algn="ctr"/>
+            <a:r>
+              <a:rPr sz="1300" b="1">
+                <a:solidFill>
+                  <a:srgbClr val="6B7280"/>
+                </a:solidFill>
+                <a:latin typeface="Segoe UI"/>
+              </a:rPr>
+              <a:t>DIAGRAM — render from Mermaid source (in speaker notes)</a:t>
+            </a:r>
+          </a:p>
+          <a:p>
+            <a:pPr algn="ctr"/>
+            <a:r>
+              <a:rPr sz="1500">
+                <a:solidFill>
+                  <a:srgbClr val="1F2A37"/>
+                </a:solidFill>
+                <a:latin typeface="Segoe UI"/>
+              </a:rPr>
+              <a:t>Role  →  Task — one clear ask  →  Context + source material  →  Format  →  Example (if shape matters)</a:t>
+            </a:r>
+          </a:p>
+        </p:txBody>
+      </p:sp>
+      <p:sp>
+        <p:nvSpPr>
+          <p:cNvPr id="6" name="TextBox 5"/>
           <p:cNvSpPr txBox="1"/>
           <p:nvPr/>
         </p:nvSpPr>
@@ -6525,7 +6728,7 @@
                 </a:solidFill>
                 <a:latin typeface="Segoe UI"/>
               </a:rPr>
-              <a:t>Next: when the model acts, not just answers</a:t>
+              <a:t>Before and after</a:t>
             </a:r>
           </a:p>
         </p:txBody>
@@ -6582,8 +6785,8 @@
         </p:nvSpPr>
         <p:spPr>
           <a:xfrm>
-            <a:off x="640080" y="1463040"/>
-            <a:ext cx="4937760" cy="4206240"/>
+            <a:off x="822960" y="1691640"/>
+            <a:ext cx="10424160" cy="4023360"/>
           </a:xfrm>
           <a:prstGeom prst="rect">
             <a:avLst/>
@@ -6602,7 +6805,7 @@
               </a:spcAft>
             </a:pPr>
             <a:r>
-              <a:rPr sz="1700">
+              <a:rPr sz="2100">
                 <a:solidFill>
                   <a:srgbClr val="2563EB"/>
                 </a:solidFill>
@@ -6611,13 +6814,13 @@
               <a:t>▪  </a:t>
             </a:r>
             <a:r>
-              <a:rPr sz="1700">
+              <a:rPr sz="2100">
                 <a:solidFill>
                   <a:srgbClr val="111827"/>
                 </a:solidFill>
                 <a:latin typeface="Segoe UI"/>
               </a:rPr>
-              <a:t>Agent = an LLM given tools + a loop → it can act (search, run code, file a ticket)</a:t>
+              <a:t>Before: "Write release notes." → invents audience, format, and content</a:t>
             </a:r>
           </a:p>
           <a:p>
@@ -6627,7 +6830,7 @@
               </a:spcAft>
             </a:pPr>
             <a:r>
-              <a:rPr sz="1700">
+              <a:rPr sz="2100">
                 <a:solidFill>
                   <a:srgbClr val="2563EB"/>
                 </a:solidFill>
@@ -6636,13 +6839,13 @@
               <a:t>▪  </a:t>
             </a:r>
             <a:r>
-              <a:rPr sz="1700">
+              <a:rPr sz="2100">
                 <a:solidFill>
                   <a:srgbClr val="111827"/>
                 </a:solidFill>
                 <a:latin typeface="Segoe UI"/>
               </a:rPr>
-              <a:t>Skill = a saved, reusable procedure that teaches it your way of doing a task</a:t>
+              <a:t>After: role + the 12 real PR titles + "group into Features/Fixes/Known Issues, one sentence each, invent nothing"</a:t>
             </a:r>
           </a:p>
           <a:p>
@@ -6652,7 +6855,7 @@
               </a:spcAft>
             </a:pPr>
             <a:r>
-              <a:rPr sz="1700">
+              <a:rPr sz="2100">
                 <a:solidFill>
                   <a:srgbClr val="2563EB"/>
                 </a:solidFill>
@@ -6661,112 +6864,20 @@
               <a:t>▪  </a:t>
             </a:r>
             <a:r>
-              <a:rPr sz="1700">
+              <a:rPr sz="2100">
                 <a:solidFill>
                   <a:srgbClr val="111827"/>
                 </a:solidFill>
                 <a:latin typeface="Segoe UI"/>
               </a:rPr>
-              <a:t>Prompt → Skill → Agent</a:t>
-            </a:r>
-          </a:p>
-          <a:p>
-            <a:pPr>
-              <a:spcAft>
-                <a:spcPts val="1400"/>
-              </a:spcAft>
-            </a:pPr>
-            <a:r>
-              <a:rPr sz="1700">
-                <a:solidFill>
-                  <a:srgbClr val="2563EB"/>
-                </a:solidFill>
-                <a:latin typeface="Segoe UI"/>
-              </a:rPr>
-              <a:t>▪  </a:t>
-            </a:r>
-            <a:r>
-              <a:rPr sz="1700">
-                <a:solidFill>
-                  <a:srgbClr val="111827"/>
-                </a:solidFill>
-                <a:latin typeface="Segoe UI"/>
-              </a:rPr>
-              <a:t>The catch: an agent acts on its output — so "own the output" matters MORE, not less</a:t>
-            </a:r>
-          </a:p>
-        </p:txBody>
-      </p:sp>
-      <p:sp>
-        <p:nvSpPr>
-          <p:cNvPr id="5" name="Rounded Rectangle 4" descr="Diagram: Next: when the model acts, not just answers"/>
-          <p:cNvSpPr/>
-          <p:nvPr/>
-        </p:nvSpPr>
-        <p:spPr>
-          <a:xfrm>
-            <a:off x="5943600" y="1554480"/>
-            <a:ext cx="5577840" cy="3840480"/>
-          </a:xfrm>
-          <a:prstGeom prst="roundRect">
-            <a:avLst/>
-          </a:prstGeom>
-          <a:solidFill>
-            <a:srgbClr val="F3F4F6"/>
-          </a:solidFill>
-          <a:ln w="12700">
-            <a:solidFill>
-              <a:srgbClr val="6B7280"/>
-            </a:solidFill>
-          </a:ln>
-          <a:effectLst/>
-        </p:spPr>
-        <p:style>
-          <a:lnRef idx="1">
-            <a:schemeClr val="accent1"/>
-          </a:lnRef>
-          <a:fillRef idx="3">
-            <a:schemeClr val="accent1"/>
-          </a:fillRef>
-          <a:effectRef idx="2">
-            <a:schemeClr val="accent1"/>
-          </a:effectRef>
-          <a:fontRef idx="minor">
-            <a:schemeClr val="lt1"/>
-          </a:fontRef>
-        </p:style>
-        <p:txBody>
-          <a:bodyPr rtlCol="0" anchor="ctr" wrap="square"/>
-          <a:lstStyle/>
-          <a:p>
-            <a:pPr algn="ctr"/>
-            <a:r>
-              <a:rPr sz="1300" b="1">
-                <a:solidFill>
-                  <a:srgbClr val="6B7280"/>
-                </a:solidFill>
-                <a:latin typeface="Segoe UI"/>
-              </a:rPr>
-              <a:t>DIAGRAM — render from Mermaid source (in speaker notes)</a:t>
-            </a:r>
-          </a:p>
-          <a:p>
-            <a:pPr algn="ctr"/>
-            <a:r>
-              <a:rPr sz="1500">
-                <a:solidFill>
-                  <a:srgbClr val="1F2A37"/>
-                </a:solidFill>
-                <a:latin typeface="Segoe UI"/>
-              </a:rPr>
-              <a:t>Prompt one-off instruction  →  Skill saved reusable procedure  →  Agent acts with tools in a loop</a:t>
-            </a:r>
-          </a:p>
-        </p:txBody>
-      </p:sp>
-      <p:sp>
-        <p:nvSpPr>
-          <p:cNvPr id="6" name="TextBox 5"/>
+              <a:t>Same model. Completely different result</a:t>
+            </a:r>
+          </a:p>
+        </p:txBody>
+      </p:sp>
+      <p:sp>
+        <p:nvSpPr>
+          <p:cNvPr id="5" name="TextBox 4"/>
           <p:cNvSpPr txBox="1"/>
           <p:nvPr/>
         </p:nvSpPr>
@@ -6855,7 +6966,7 @@
                 </a:solidFill>
                 <a:latin typeface="Segoe UI"/>
               </a:rPr>
-              <a:t>Take away six things</a:t>
+              <a:t>Next: when the model acts, not just answers (agents)</a:t>
             </a:r>
           </a:p>
         </p:txBody>
@@ -6912,8 +7023,8 @@
         </p:nvSpPr>
         <p:spPr>
           <a:xfrm>
-            <a:off x="822960" y="1691640"/>
-            <a:ext cx="10424160" cy="4023360"/>
+            <a:off x="640080" y="1463040"/>
+            <a:ext cx="4937760" cy="4206240"/>
           </a:xfrm>
           <a:prstGeom prst="rect">
             <a:avLst/>
@@ -6932,7 +7043,7 @@
               </a:spcAft>
             </a:pPr>
             <a:r>
-              <a:rPr sz="2100">
+              <a:rPr sz="1700">
                 <a:solidFill>
                   <a:srgbClr val="2563EB"/>
                 </a:solidFill>
@@ -6941,13 +7052,13 @@
               <a:t>▪  </a:t>
             </a:r>
             <a:r>
-              <a:rPr sz="2100">
+              <a:rPr sz="1700">
                 <a:solidFill>
                   <a:srgbClr val="111827"/>
                 </a:solidFill>
                 <a:latin typeface="Segoe UI"/>
               </a:rPr>
-              <a:t>1. Learns from examples, not rules</a:t>
+              <a:t>An agent = an LLM given tools + a loop</a:t>
             </a:r>
           </a:p>
           <a:p>
@@ -6957,7 +7068,7 @@
               </a:spcAft>
             </a:pPr>
             <a:r>
-              <a:rPr sz="2100">
+              <a:rPr sz="1700">
                 <a:solidFill>
                   <a:srgbClr val="2563EB"/>
                 </a:solidFill>
@@ -6966,13 +7077,13 @@
               <a:t>▪  </a:t>
             </a:r>
             <a:r>
-              <a:rPr sz="2100">
+              <a:rPr sz="1700">
                 <a:solidFill>
                   <a:srgbClr val="111827"/>
                 </a:solidFill>
                 <a:latin typeface="Segoe UI"/>
               </a:rPr>
-              <a:t>2. Autocomplete on steroids — doesn't look things up</a:t>
+              <a:t>It doesn't just reply — it searches, runs code, reads a file, files a ticket, then decides the next step</a:t>
             </a:r>
           </a:p>
           <a:p>
@@ -6982,7 +7093,7 @@
               </a:spcAft>
             </a:pPr>
             <a:r>
-              <a:rPr sz="2100">
+              <a:rPr sz="1700">
                 <a:solidFill>
                   <a:srgbClr val="2563EB"/>
                 </a:solidFill>
@@ -6991,13 +7102,13 @@
               <a:t>▪  </a:t>
             </a:r>
             <a:r>
-              <a:rPr sz="2100">
+              <a:rPr sz="1700">
                 <a:solidFill>
                   <a:srgbClr val="111827"/>
                 </a:solidFill>
                 <a:latin typeface="Segoe UI"/>
               </a:rPr>
-              <a:t>3. Hallucination is structural; confidence ≠ truth</a:t>
+              <a:t>Think → Act → Observe → repeat</a:t>
             </a:r>
           </a:p>
           <a:p>
@@ -7007,7 +7118,7 @@
               </a:spcAft>
             </a:pPr>
             <a:r>
-              <a:rPr sz="2100">
+              <a:rPr sz="1700">
                 <a:solidFill>
                   <a:srgbClr val="2563EB"/>
                 </a:solidFill>
@@ -7016,70 +7127,87 @@
               <a:t>▪  </a:t>
             </a:r>
             <a:r>
-              <a:rPr sz="2100">
+              <a:rPr sz="1700">
                 <a:solidFill>
                   <a:srgbClr val="111827"/>
                 </a:solidFill>
                 <a:latin typeface="Segoe UI"/>
               </a:rPr>
-              <a:t>4. Use where you can verify, or truth doesn't matter — own the output</a:t>
-            </a:r>
-          </a:p>
-          <a:p>
-            <a:pPr>
-              <a:spcAft>
-                <a:spcPts val="1400"/>
-              </a:spcAft>
-            </a:pPr>
-            <a:r>
-              <a:rPr sz="2100">
-                <a:solidFill>
-                  <a:srgbClr val="2563EB"/>
-                </a:solidFill>
-                <a:latin typeface="Segoe UI"/>
-              </a:rPr>
-              <a:t>▪  </a:t>
-            </a:r>
-            <a:r>
-              <a:rPr sz="2100">
-                <a:solidFill>
-                  <a:srgbClr val="111827"/>
-                </a:solidFill>
-                <a:latin typeface="Segoe UI"/>
-              </a:rPr>
-              <a:t>5. Good prompts are clear briefs, not magic words</a:t>
-            </a:r>
-          </a:p>
-          <a:p>
-            <a:pPr>
-              <a:spcAft>
-                <a:spcPts val="1400"/>
-              </a:spcAft>
-            </a:pPr>
-            <a:r>
-              <a:rPr sz="2100">
-                <a:solidFill>
-                  <a:srgbClr val="2563EB"/>
-                </a:solidFill>
-                <a:latin typeface="Segoe UI"/>
-              </a:rPr>
-              <a:t>▪  </a:t>
-            </a:r>
-            <a:r>
-              <a:rPr sz="2100">
-                <a:solidFill>
-                  <a:srgbClr val="111827"/>
-                </a:solidFill>
-                <a:latin typeface="Segoe UI"/>
-              </a:rPr>
-              <a:t>6. Agents act, skills make them consistent — owning the output matters more once it acts</a:t>
-            </a:r>
-          </a:p>
-        </p:txBody>
-      </p:sp>
-      <p:sp>
-        <p:nvSpPr>
-          <p:cNvPr id="5" name="TextBox 4"/>
+              <a:t>The catch: it acts on its output, so a wrong answer becomes an incident, not just an embarrassment</a:t>
+            </a:r>
+          </a:p>
+        </p:txBody>
+      </p:sp>
+      <p:sp>
+        <p:nvSpPr>
+          <p:cNvPr id="5" name="Rounded Rectangle 4" descr="Diagram: Next: when the model acts, not just answers (agents)"/>
+          <p:cNvSpPr/>
+          <p:nvPr/>
+        </p:nvSpPr>
+        <p:spPr>
+          <a:xfrm>
+            <a:off x="5943600" y="1554480"/>
+            <a:ext cx="5577840" cy="3840480"/>
+          </a:xfrm>
+          <a:prstGeom prst="roundRect">
+            <a:avLst/>
+          </a:prstGeom>
+          <a:solidFill>
+            <a:srgbClr val="F3F4F6"/>
+          </a:solidFill>
+          <a:ln w="12700">
+            <a:solidFill>
+              <a:srgbClr val="6B7280"/>
+            </a:solidFill>
+          </a:ln>
+          <a:effectLst/>
+        </p:spPr>
+        <p:style>
+          <a:lnRef idx="1">
+            <a:schemeClr val="accent1"/>
+          </a:lnRef>
+          <a:fillRef idx="3">
+            <a:schemeClr val="accent1"/>
+          </a:fillRef>
+          <a:effectRef idx="2">
+            <a:schemeClr val="accent1"/>
+          </a:effectRef>
+          <a:fontRef idx="minor">
+            <a:schemeClr val="lt1"/>
+          </a:fontRef>
+        </p:style>
+        <p:txBody>
+          <a:bodyPr rtlCol="0" anchor="ctr" wrap="square"/>
+          <a:lstStyle/>
+          <a:p>
+            <a:pPr algn="ctr"/>
+            <a:r>
+              <a:rPr sz="1300" b="1">
+                <a:solidFill>
+                  <a:srgbClr val="6B7280"/>
+                </a:solidFill>
+                <a:latin typeface="Segoe UI"/>
+              </a:rPr>
+              <a:t>DIAGRAM — render from Mermaid source (in speaker notes)</a:t>
+            </a:r>
+          </a:p>
+          <a:p>
+            <a:pPr algn="ctr"/>
+            <a:r>
+              <a:rPr sz="1500">
+                <a:solidFill>
+                  <a:srgbClr val="1F2A37"/>
+                </a:solidFill>
+                <a:latin typeface="Segoe UI"/>
+              </a:rPr>
+              <a:t>Goal  →  Think: next step?  →  Act: use a tool  →  Observe: read result  →  Done</a:t>
+            </a:r>
+          </a:p>
+        </p:txBody>
+      </p:sp>
+      <p:sp>
+        <p:nvSpPr>
+          <p:cNvPr id="6" name="TextBox 5"/>
           <p:cNvSpPr txBox="1"/>
           <p:nvPr/>
         </p:nvSpPr>
@@ -7125,6 +7253,674 @@
 </file>
 
 <file path=ppt/slides/slide17.xml><?xml version="1.0" encoding="utf-8"?>
+<p:sld xmlns:a="http://schemas.openxmlformats.org/drawingml/2006/main" xmlns:p="http://schemas.openxmlformats.org/presentationml/2006/main" xmlns:r="http://schemas.openxmlformats.org/officeDocument/2006/relationships">
+  <p:cSld>
+    <p:spTree>
+      <p:nvGrpSpPr>
+        <p:cNvPr id="1" name=""/>
+        <p:cNvGrpSpPr/>
+        <p:nvPr/>
+      </p:nvGrpSpPr>
+      <p:grpSpPr/>
+      <p:sp>
+        <p:nvSpPr>
+          <p:cNvPr id="2" name="TextBox 1"/>
+          <p:cNvSpPr txBox="1"/>
+          <p:nvPr/>
+        </p:nvSpPr>
+        <p:spPr>
+          <a:xfrm>
+            <a:off x="640080" y="502920"/>
+            <a:ext cx="10881360" cy="731520"/>
+          </a:xfrm>
+          <a:prstGeom prst="rect">
+            <a:avLst/>
+          </a:prstGeom>
+          <a:noFill/>
+        </p:spPr>
+        <p:txBody>
+          <a:bodyPr wrap="square" anchor="t">
+            <a:spAutoFit/>
+          </a:bodyPr>
+          <a:lstStyle/>
+          <a:p>
+            <a:pPr algn="l">
+              <a:spcAft>
+                <a:spcPts val="1000"/>
+              </a:spcAft>
+            </a:pPr>
+            <a:r>
+              <a:rPr sz="2800" b="1">
+                <a:solidFill>
+                  <a:srgbClr val="1F2A37"/>
+                </a:solidFill>
+                <a:latin typeface="Segoe UI"/>
+              </a:rPr>
+              <a:t>Skills: teaching it your way, once</a:t>
+            </a:r>
+          </a:p>
+        </p:txBody>
+      </p:sp>
+      <p:sp>
+        <p:nvSpPr>
+          <p:cNvPr id="3" name="Rectangle 2"/>
+          <p:cNvSpPr/>
+          <p:nvPr/>
+        </p:nvSpPr>
+        <p:spPr>
+          <a:xfrm>
+            <a:off x="640080" y="1170432"/>
+            <a:ext cx="1005840" cy="50800"/>
+          </a:xfrm>
+          <a:prstGeom prst="rect">
+            <a:avLst/>
+          </a:prstGeom>
+          <a:solidFill>
+            <a:srgbClr val="2563EB"/>
+          </a:solidFill>
+          <a:ln>
+            <a:noFill/>
+          </a:ln>
+          <a:effectLst/>
+        </p:spPr>
+        <p:style>
+          <a:lnRef idx="1">
+            <a:schemeClr val="accent1"/>
+          </a:lnRef>
+          <a:fillRef idx="3">
+            <a:schemeClr val="accent1"/>
+          </a:fillRef>
+          <a:effectRef idx="2">
+            <a:schemeClr val="accent1"/>
+          </a:effectRef>
+          <a:fontRef idx="minor">
+            <a:schemeClr val="lt1"/>
+          </a:fontRef>
+        </p:style>
+        <p:txBody>
+          <a:bodyPr rtlCol="0" anchor="ctr"/>
+          <a:lstStyle/>
+          <a:p>
+            <a:pPr algn="ctr"/>
+          </a:p>
+        </p:txBody>
+      </p:sp>
+      <p:sp>
+        <p:nvSpPr>
+          <p:cNvPr id="4" name="TextBox 3"/>
+          <p:cNvSpPr txBox="1"/>
+          <p:nvPr/>
+        </p:nvSpPr>
+        <p:spPr>
+          <a:xfrm>
+            <a:off x="640080" y="1463040"/>
+            <a:ext cx="4937760" cy="4206240"/>
+          </a:xfrm>
+          <a:prstGeom prst="rect">
+            <a:avLst/>
+          </a:prstGeom>
+          <a:noFill/>
+        </p:spPr>
+        <p:txBody>
+          <a:bodyPr wrap="square">
+            <a:spAutoFit/>
+          </a:bodyPr>
+          <a:lstStyle/>
+          <a:p>
+            <a:pPr>
+              <a:spcAft>
+                <a:spcPts val="1400"/>
+              </a:spcAft>
+            </a:pPr>
+            <a:r>
+              <a:rPr sz="1700">
+                <a:solidFill>
+                  <a:srgbClr val="2563EB"/>
+                </a:solidFill>
+                <a:latin typeface="Segoe UI"/>
+              </a:rPr>
+              <a:t>▪  </a:t>
+            </a:r>
+            <a:r>
+              <a:rPr sz="1700">
+                <a:solidFill>
+                  <a:srgbClr val="111827"/>
+                </a:solidFill>
+                <a:latin typeface="Segoe UI"/>
+              </a:rPr>
+              <a:t>A skill = a saved, reusable procedure that teaches the model how you do a task</a:t>
+            </a:r>
+          </a:p>
+          <a:p>
+            <a:pPr>
+              <a:spcAft>
+                <a:spcPts val="1400"/>
+              </a:spcAft>
+            </a:pPr>
+            <a:r>
+              <a:rPr sz="1700">
+                <a:solidFill>
+                  <a:srgbClr val="2563EB"/>
+                </a:solidFill>
+                <a:latin typeface="Segoe UI"/>
+              </a:rPr>
+              <a:t>▪  </a:t>
+            </a:r>
+            <a:r>
+              <a:rPr sz="1700">
+                <a:solidFill>
+                  <a:srgbClr val="111827"/>
+                </a:solidFill>
+                <a:latin typeface="Segoe UI"/>
+              </a:rPr>
+              <a:t>Prompt = a one-off instruction</a:t>
+            </a:r>
+          </a:p>
+          <a:p>
+            <a:pPr>
+              <a:spcAft>
+                <a:spcPts val="1400"/>
+              </a:spcAft>
+            </a:pPr>
+            <a:r>
+              <a:rPr sz="1700">
+                <a:solidFill>
+                  <a:srgbClr val="2563EB"/>
+                </a:solidFill>
+                <a:latin typeface="Segoe UI"/>
+              </a:rPr>
+              <a:t>▪  </a:t>
+            </a:r>
+            <a:r>
+              <a:rPr sz="1700">
+                <a:solidFill>
+                  <a:srgbClr val="111827"/>
+                </a:solidFill>
+                <a:latin typeface="Segoe UI"/>
+              </a:rPr>
+              <a:t>Skill = a written how-to it reuses every time</a:t>
+            </a:r>
+          </a:p>
+          <a:p>
+            <a:pPr>
+              <a:spcAft>
+                <a:spcPts val="1400"/>
+              </a:spcAft>
+            </a:pPr>
+            <a:r>
+              <a:rPr sz="1700">
+                <a:solidFill>
+                  <a:srgbClr val="2563EB"/>
+                </a:solidFill>
+                <a:latin typeface="Segoe UI"/>
+              </a:rPr>
+              <a:t>▪  </a:t>
+            </a:r>
+            <a:r>
+              <a:rPr sz="1700">
+                <a:solidFill>
+                  <a:srgbClr val="111827"/>
+                </a:solidFill>
+                <a:latin typeface="Segoe UI"/>
+              </a:rPr>
+              <a:t>Skills make chats AND agents consistent and expert at YOUR work, not just generically capable</a:t>
+            </a:r>
+          </a:p>
+          <a:p>
+            <a:pPr>
+              <a:spcAft>
+                <a:spcPts val="1400"/>
+              </a:spcAft>
+            </a:pPr>
+            <a:r>
+              <a:rPr sz="1700">
+                <a:solidFill>
+                  <a:srgbClr val="2563EB"/>
+                </a:solidFill>
+                <a:latin typeface="Segoe UI"/>
+              </a:rPr>
+              <a:t>▪  </a:t>
+            </a:r>
+            <a:r>
+              <a:rPr sz="1700">
+                <a:solidFill>
+                  <a:srgbClr val="111827"/>
+                </a:solidFill>
+                <a:latin typeface="Segoe UI"/>
+              </a:rPr>
+              <a:t>Prompt → Skill → Agent</a:t>
+            </a:r>
+          </a:p>
+        </p:txBody>
+      </p:sp>
+      <p:sp>
+        <p:nvSpPr>
+          <p:cNvPr id="5" name="Rounded Rectangle 4" descr="Diagram: Skills: teaching it your way, once"/>
+          <p:cNvSpPr/>
+          <p:nvPr/>
+        </p:nvSpPr>
+        <p:spPr>
+          <a:xfrm>
+            <a:off x="5943600" y="1554480"/>
+            <a:ext cx="5577840" cy="3840480"/>
+          </a:xfrm>
+          <a:prstGeom prst="roundRect">
+            <a:avLst/>
+          </a:prstGeom>
+          <a:solidFill>
+            <a:srgbClr val="F3F4F6"/>
+          </a:solidFill>
+          <a:ln w="12700">
+            <a:solidFill>
+              <a:srgbClr val="6B7280"/>
+            </a:solidFill>
+          </a:ln>
+          <a:effectLst/>
+        </p:spPr>
+        <p:style>
+          <a:lnRef idx="1">
+            <a:schemeClr val="accent1"/>
+          </a:lnRef>
+          <a:fillRef idx="3">
+            <a:schemeClr val="accent1"/>
+          </a:fillRef>
+          <a:effectRef idx="2">
+            <a:schemeClr val="accent1"/>
+          </a:effectRef>
+          <a:fontRef idx="minor">
+            <a:schemeClr val="lt1"/>
+          </a:fontRef>
+        </p:style>
+        <p:txBody>
+          <a:bodyPr rtlCol="0" anchor="ctr" wrap="square"/>
+          <a:lstStyle/>
+          <a:p>
+            <a:pPr algn="ctr"/>
+            <a:r>
+              <a:rPr sz="1300" b="1">
+                <a:solidFill>
+                  <a:srgbClr val="6B7280"/>
+                </a:solidFill>
+                <a:latin typeface="Segoe UI"/>
+              </a:rPr>
+              <a:t>DIAGRAM — render from Mermaid source (in speaker notes)</a:t>
+            </a:r>
+          </a:p>
+          <a:p>
+            <a:pPr algn="ctr"/>
+            <a:r>
+              <a:rPr sz="1500">
+                <a:solidFill>
+                  <a:srgbClr val="1F2A37"/>
+                </a:solidFill>
+                <a:latin typeface="Segoe UI"/>
+              </a:rPr>
+              <a:t>Prompt one-off instruction  →  Skill saved reusable procedure  →  Agent acts with tools in a loop</a:t>
+            </a:r>
+          </a:p>
+        </p:txBody>
+      </p:sp>
+      <p:sp>
+        <p:nvSpPr>
+          <p:cNvPr id="6" name="TextBox 5"/>
+          <p:cNvSpPr txBox="1"/>
+          <p:nvPr/>
+        </p:nvSpPr>
+        <p:spPr>
+          <a:xfrm>
+            <a:off x="640080" y="6327648"/>
+            <a:ext cx="6858000" cy="365760"/>
+          </a:xfrm>
+          <a:prstGeom prst="rect">
+            <a:avLst/>
+          </a:prstGeom>
+          <a:noFill/>
+        </p:spPr>
+        <p:txBody>
+          <a:bodyPr wrap="square" anchor="t">
+            <a:spAutoFit/>
+          </a:bodyPr>
+          <a:lstStyle/>
+          <a:p>
+            <a:pPr algn="l">
+              <a:spcAft>
+                <a:spcPts val="1000"/>
+              </a:spcAft>
+            </a:pPr>
+            <a:r>
+              <a:rPr sz="1100" b="0">
+                <a:solidFill>
+                  <a:srgbClr val="6B7280"/>
+                </a:solidFill>
+                <a:latin typeface="Segoe UI"/>
+              </a:rPr>
+              <a:t>AI Training Series</a:t>
+            </a:r>
+          </a:p>
+        </p:txBody>
+      </p:sp>
+    </p:spTree>
+  </p:cSld>
+  <p:clrMapOvr>
+    <a:masterClrMapping/>
+  </p:clrMapOvr>
+</p:sld>
+</file>
+
+<file path=ppt/slides/slide18.xml><?xml version="1.0" encoding="utf-8"?>
+<p:sld xmlns:a="http://schemas.openxmlformats.org/drawingml/2006/main" xmlns:p="http://schemas.openxmlformats.org/presentationml/2006/main" xmlns:r="http://schemas.openxmlformats.org/officeDocument/2006/relationships">
+  <p:cSld>
+    <p:spTree>
+      <p:nvGrpSpPr>
+        <p:cNvPr id="1" name=""/>
+        <p:cNvGrpSpPr/>
+        <p:nvPr/>
+      </p:nvGrpSpPr>
+      <p:grpSpPr/>
+      <p:sp>
+        <p:nvSpPr>
+          <p:cNvPr id="2" name="TextBox 1"/>
+          <p:cNvSpPr txBox="1"/>
+          <p:nvPr/>
+        </p:nvSpPr>
+        <p:spPr>
+          <a:xfrm>
+            <a:off x="640080" y="502920"/>
+            <a:ext cx="10881360" cy="731520"/>
+          </a:xfrm>
+          <a:prstGeom prst="rect">
+            <a:avLst/>
+          </a:prstGeom>
+          <a:noFill/>
+        </p:spPr>
+        <p:txBody>
+          <a:bodyPr wrap="square" anchor="t">
+            <a:spAutoFit/>
+          </a:bodyPr>
+          <a:lstStyle/>
+          <a:p>
+            <a:pPr algn="l">
+              <a:spcAft>
+                <a:spcPts val="1000"/>
+              </a:spcAft>
+            </a:pPr>
+            <a:r>
+              <a:rPr sz="2800" b="1">
+                <a:solidFill>
+                  <a:srgbClr val="1F2A37"/>
+                </a:solidFill>
+                <a:latin typeface="Segoe UI"/>
+              </a:rPr>
+              <a:t>Take away six things</a:t>
+            </a:r>
+          </a:p>
+        </p:txBody>
+      </p:sp>
+      <p:sp>
+        <p:nvSpPr>
+          <p:cNvPr id="3" name="Rectangle 2"/>
+          <p:cNvSpPr/>
+          <p:nvPr/>
+        </p:nvSpPr>
+        <p:spPr>
+          <a:xfrm>
+            <a:off x="640080" y="1170432"/>
+            <a:ext cx="1005840" cy="50800"/>
+          </a:xfrm>
+          <a:prstGeom prst="rect">
+            <a:avLst/>
+          </a:prstGeom>
+          <a:solidFill>
+            <a:srgbClr val="2563EB"/>
+          </a:solidFill>
+          <a:ln>
+            <a:noFill/>
+          </a:ln>
+          <a:effectLst/>
+        </p:spPr>
+        <p:style>
+          <a:lnRef idx="1">
+            <a:schemeClr val="accent1"/>
+          </a:lnRef>
+          <a:fillRef idx="3">
+            <a:schemeClr val="accent1"/>
+          </a:fillRef>
+          <a:effectRef idx="2">
+            <a:schemeClr val="accent1"/>
+          </a:effectRef>
+          <a:fontRef idx="minor">
+            <a:schemeClr val="lt1"/>
+          </a:fontRef>
+        </p:style>
+        <p:txBody>
+          <a:bodyPr rtlCol="0" anchor="ctr"/>
+          <a:lstStyle/>
+          <a:p>
+            <a:pPr algn="ctr"/>
+          </a:p>
+        </p:txBody>
+      </p:sp>
+      <p:sp>
+        <p:nvSpPr>
+          <p:cNvPr id="4" name="TextBox 3"/>
+          <p:cNvSpPr txBox="1"/>
+          <p:nvPr/>
+        </p:nvSpPr>
+        <p:spPr>
+          <a:xfrm>
+            <a:off x="822960" y="1691640"/>
+            <a:ext cx="10424160" cy="4023360"/>
+          </a:xfrm>
+          <a:prstGeom prst="rect">
+            <a:avLst/>
+          </a:prstGeom>
+          <a:noFill/>
+        </p:spPr>
+        <p:txBody>
+          <a:bodyPr wrap="square">
+            <a:spAutoFit/>
+          </a:bodyPr>
+          <a:lstStyle/>
+          <a:p>
+            <a:pPr>
+              <a:spcAft>
+                <a:spcPts val="1400"/>
+              </a:spcAft>
+            </a:pPr>
+            <a:r>
+              <a:rPr sz="2100">
+                <a:solidFill>
+                  <a:srgbClr val="2563EB"/>
+                </a:solidFill>
+                <a:latin typeface="Segoe UI"/>
+              </a:rPr>
+              <a:t>▪  </a:t>
+            </a:r>
+            <a:r>
+              <a:rPr sz="2100">
+                <a:solidFill>
+                  <a:srgbClr val="111827"/>
+                </a:solidFill>
+                <a:latin typeface="Segoe UI"/>
+              </a:rPr>
+              <a:t>1. Learns from examples, not rules</a:t>
+            </a:r>
+          </a:p>
+          <a:p>
+            <a:pPr>
+              <a:spcAft>
+                <a:spcPts val="1400"/>
+              </a:spcAft>
+            </a:pPr>
+            <a:r>
+              <a:rPr sz="2100">
+                <a:solidFill>
+                  <a:srgbClr val="2563EB"/>
+                </a:solidFill>
+                <a:latin typeface="Segoe UI"/>
+              </a:rPr>
+              <a:t>▪  </a:t>
+            </a:r>
+            <a:r>
+              <a:rPr sz="2100">
+                <a:solidFill>
+                  <a:srgbClr val="111827"/>
+                </a:solidFill>
+                <a:latin typeface="Segoe UI"/>
+              </a:rPr>
+              <a:t>2. Autocomplete on steroids — doesn't look things up</a:t>
+            </a:r>
+          </a:p>
+          <a:p>
+            <a:pPr>
+              <a:spcAft>
+                <a:spcPts val="1400"/>
+              </a:spcAft>
+            </a:pPr>
+            <a:r>
+              <a:rPr sz="2100">
+                <a:solidFill>
+                  <a:srgbClr val="2563EB"/>
+                </a:solidFill>
+                <a:latin typeface="Segoe UI"/>
+              </a:rPr>
+              <a:t>▪  </a:t>
+            </a:r>
+            <a:r>
+              <a:rPr sz="2100">
+                <a:solidFill>
+                  <a:srgbClr val="111827"/>
+                </a:solidFill>
+                <a:latin typeface="Segoe UI"/>
+              </a:rPr>
+              <a:t>3. Hallucination is structural; confidence ≠ truth</a:t>
+            </a:r>
+          </a:p>
+          <a:p>
+            <a:pPr>
+              <a:spcAft>
+                <a:spcPts val="1400"/>
+              </a:spcAft>
+            </a:pPr>
+            <a:r>
+              <a:rPr sz="2100">
+                <a:solidFill>
+                  <a:srgbClr val="2563EB"/>
+                </a:solidFill>
+                <a:latin typeface="Segoe UI"/>
+              </a:rPr>
+              <a:t>▪  </a:t>
+            </a:r>
+            <a:r>
+              <a:rPr sz="2100">
+                <a:solidFill>
+                  <a:srgbClr val="111827"/>
+                </a:solidFill>
+                <a:latin typeface="Segoe UI"/>
+              </a:rPr>
+              <a:t>4. Use where you can verify, or truth doesn't matter — own the output</a:t>
+            </a:r>
+          </a:p>
+          <a:p>
+            <a:pPr>
+              <a:spcAft>
+                <a:spcPts val="1400"/>
+              </a:spcAft>
+            </a:pPr>
+            <a:r>
+              <a:rPr sz="2100">
+                <a:solidFill>
+                  <a:srgbClr val="2563EB"/>
+                </a:solidFill>
+                <a:latin typeface="Segoe UI"/>
+              </a:rPr>
+              <a:t>▪  </a:t>
+            </a:r>
+            <a:r>
+              <a:rPr sz="2100">
+                <a:solidFill>
+                  <a:srgbClr val="111827"/>
+                </a:solidFill>
+                <a:latin typeface="Segoe UI"/>
+              </a:rPr>
+              <a:t>5. Good prompts are clear briefs, not magic words</a:t>
+            </a:r>
+          </a:p>
+          <a:p>
+            <a:pPr>
+              <a:spcAft>
+                <a:spcPts val="1400"/>
+              </a:spcAft>
+            </a:pPr>
+            <a:r>
+              <a:rPr sz="2100">
+                <a:solidFill>
+                  <a:srgbClr val="2563EB"/>
+                </a:solidFill>
+                <a:latin typeface="Segoe UI"/>
+              </a:rPr>
+              <a:t>▪  </a:t>
+            </a:r>
+            <a:r>
+              <a:rPr sz="2100">
+                <a:solidFill>
+                  <a:srgbClr val="111827"/>
+                </a:solidFill>
+                <a:latin typeface="Segoe UI"/>
+              </a:rPr>
+              <a:t>6. Agents act, skills make them consistent — owning the output matters more once it acts</a:t>
+            </a:r>
+          </a:p>
+        </p:txBody>
+      </p:sp>
+      <p:sp>
+        <p:nvSpPr>
+          <p:cNvPr id="5" name="TextBox 4"/>
+          <p:cNvSpPr txBox="1"/>
+          <p:nvPr/>
+        </p:nvSpPr>
+        <p:spPr>
+          <a:xfrm>
+            <a:off x="640080" y="6327648"/>
+            <a:ext cx="6858000" cy="365760"/>
+          </a:xfrm>
+          <a:prstGeom prst="rect">
+            <a:avLst/>
+          </a:prstGeom>
+          <a:noFill/>
+        </p:spPr>
+        <p:txBody>
+          <a:bodyPr wrap="square" anchor="t">
+            <a:spAutoFit/>
+          </a:bodyPr>
+          <a:lstStyle/>
+          <a:p>
+            <a:pPr algn="l">
+              <a:spcAft>
+                <a:spcPts val="1000"/>
+              </a:spcAft>
+            </a:pPr>
+            <a:r>
+              <a:rPr sz="1100" b="0">
+                <a:solidFill>
+                  <a:srgbClr val="6B7280"/>
+                </a:solidFill>
+                <a:latin typeface="Segoe UI"/>
+              </a:rPr>
+              <a:t>AI Training Series</a:t>
+            </a:r>
+          </a:p>
+        </p:txBody>
+      </p:sp>
+    </p:spTree>
+  </p:cSld>
+  <p:clrMapOvr>
+    <a:masterClrMapping/>
+  </p:clrMapOvr>
+</p:sld>
+</file>
+
+<file path=ppt/slides/slide19.xml><?xml version="1.0" encoding="utf-8"?>
 <p:sld xmlns:a="http://schemas.openxmlformats.org/drawingml/2006/main" xmlns:p="http://schemas.openxmlformats.org/presentationml/2006/main" xmlns:r="http://schemas.openxmlformats.org/officeDocument/2006/relationships">
   <p:cSld>
     <p:spTree>

</xml_diff>